<commit_message>
refactor: centralize presentation styling into shared palette and standardize slide generation logic
</commit_message>
<xml_diff>
--- a/paper-research/academic-context/ppt-build/CMatrix_Presentation.pptx
+++ b/paper-research/academic-context/ppt-build/CMatrix_Presentation.pptx
@@ -3247,26 +3247,23 @@
         </p:nvSpPr>
         <p:spPr>
           <a:xfrm>
-            <a:off x="5943600" y="1188720"/>
-            <a:ext cx="5943600" cy="5029200"/>
-          </a:xfrm>
-          <a:prstGeom prst="rect">
-            <a:avLst/>
-          </a:prstGeom>
-          <a:noFill/>
-        </p:spPr>
-        <p:txBody>
-          <a:bodyPr wrap="square">
+            <a:off x="4114800" y="731520"/>
+            <a:ext cx="8046720" cy="5303520"/>
+          </a:xfrm>
+          <a:prstGeom prst="rect">
+            <a:avLst/>
+          </a:prstGeom>
+          <a:noFill/>
+        </p:spPr>
+        <p:txBody>
+          <a:bodyPr wrap="none">
             <a:spAutoFit/>
           </a:bodyPr>
           <a:lstStyle/>
           <a:p>
             <a:pPr algn="r"/>
             <a:r>
-              <a:rPr sz="13000" b="1" i="0">
-                <a:solidFill>
-                  <a:srgbClr val="0D2535"/>
-                </a:solidFill>
+              <a:rPr sz="13000" b="1">
                 <a:latin typeface="Calibri"/>
               </a:rPr>
               <a:t>CMATRIX</a:t>
@@ -3282,8 +3279,8 @@
         </p:nvSpPr>
         <p:spPr>
           <a:xfrm>
-            <a:off x="457200" y="731520"/>
-            <a:ext cx="7315200" cy="502920"/>
+            <a:off x="457200" y="777240"/>
+            <a:ext cx="7315200" cy="411480"/>
           </a:xfrm>
           <a:prstGeom prst="rect">
             <a:avLst/>
@@ -3317,8 +3314,8 @@
         </p:nvSpPr>
         <p:spPr>
           <a:xfrm>
-            <a:off x="457200" y="1188720"/>
-            <a:ext cx="8046720" cy="1828800"/>
+            <a:off x="457200" y="1234440"/>
+            <a:ext cx="8046720" cy="1737360"/>
           </a:xfrm>
           <a:prstGeom prst="rect">
             <a:avLst/>
@@ -3352,7 +3349,7 @@
         </p:nvSpPr>
         <p:spPr>
           <a:xfrm>
-            <a:off x="457200" y="2743200"/>
+            <a:off x="457200" y="2788920"/>
             <a:ext cx="8686800" cy="1097280"/>
           </a:xfrm>
           <a:prstGeom prst="rect">
@@ -3388,7 +3385,7 @@
         </p:nvSpPr>
         <p:spPr>
           <a:xfrm>
-            <a:off x="457200" y="3886200"/>
+            <a:off x="457200" y="3913632"/>
             <a:ext cx="5943600" cy="27432"/>
           </a:xfrm>
           <a:prstGeom prst="rect">
@@ -3432,8 +3429,8 @@
         </p:nvSpPr>
         <p:spPr>
           <a:xfrm>
-            <a:off x="457200" y="4023360"/>
-            <a:ext cx="2468880" cy="384048"/>
+            <a:off x="457200" y="4069080"/>
+            <a:ext cx="2514600" cy="384048"/>
           </a:xfrm>
           <a:prstGeom prst="rect">
             <a:avLst/>
@@ -3478,8 +3475,8 @@
         </p:nvSpPr>
         <p:spPr>
           <a:xfrm>
-            <a:off x="530352" y="4050791"/>
-            <a:ext cx="2331720" cy="347472"/>
+            <a:off x="548640" y="4096512"/>
+            <a:ext cx="2377440" cy="329184"/>
           </a:xfrm>
           <a:prstGeom prst="rect">
             <a:avLst/>
@@ -3513,8 +3510,8 @@
         </p:nvSpPr>
         <p:spPr>
           <a:xfrm>
-            <a:off x="3200400" y="4023360"/>
-            <a:ext cx="2468880" cy="384048"/>
+            <a:off x="3246120" y="4069080"/>
+            <a:ext cx="2514600" cy="384048"/>
           </a:xfrm>
           <a:prstGeom prst="rect">
             <a:avLst/>
@@ -3559,8 +3556,8 @@
         </p:nvSpPr>
         <p:spPr>
           <a:xfrm>
-            <a:off x="3273552" y="4050791"/>
-            <a:ext cx="2331720" cy="347472"/>
+            <a:off x="3337560" y="4096512"/>
+            <a:ext cx="2377440" cy="329184"/>
           </a:xfrm>
           <a:prstGeom prst="rect">
             <a:avLst/>
@@ -3594,8 +3591,8 @@
         </p:nvSpPr>
         <p:spPr>
           <a:xfrm>
-            <a:off x="5943600" y="4023360"/>
-            <a:ext cx="2468880" cy="384048"/>
+            <a:off x="6035040" y="4069080"/>
+            <a:ext cx="2514600" cy="384048"/>
           </a:xfrm>
           <a:prstGeom prst="rect">
             <a:avLst/>
@@ -3640,8 +3637,8 @@
         </p:nvSpPr>
         <p:spPr>
           <a:xfrm>
-            <a:off x="6016752" y="4050791"/>
-            <a:ext cx="2331720" cy="347472"/>
+            <a:off x="6126480" y="4096512"/>
+            <a:ext cx="2377440" cy="329184"/>
           </a:xfrm>
           <a:prstGeom prst="rect">
             <a:avLst/>
@@ -3675,8 +3672,8 @@
         </p:nvSpPr>
         <p:spPr>
           <a:xfrm>
-            <a:off x="457200" y="4709160"/>
-            <a:ext cx="7315200" cy="365760"/>
+            <a:off x="457200" y="4754880"/>
+            <a:ext cx="7315200" cy="347472"/>
           </a:xfrm>
           <a:prstGeom prst="rect">
             <a:avLst/>
@@ -3710,8 +3707,8 @@
         </p:nvSpPr>
         <p:spPr>
           <a:xfrm>
-            <a:off x="457200" y="5120640"/>
-            <a:ext cx="9144000" cy="365760"/>
+            <a:off x="457200" y="5138928"/>
+            <a:ext cx="9144000" cy="347472"/>
           </a:xfrm>
           <a:prstGeom prst="rect">
             <a:avLst/>
@@ -3732,7 +3729,7 @@
                 </a:solidFill>
                 <a:latin typeface="Calibri"/>
               </a:rPr>
-              <a:t>Black-Box &amp; Grey-Box Assessment  ·  Network · Web · REST API</a:t>
+              <a:t>Black-Box &amp; Grey-Box Assessment  ·  Network  ·  Web  ·  REST API</a:t>
             </a:r>
           </a:p>
         </p:txBody>
@@ -3745,8 +3742,8 @@
         </p:nvSpPr>
         <p:spPr>
           <a:xfrm>
-            <a:off x="11368735" y="6355080"/>
-            <a:ext cx="640080" cy="411480"/>
+            <a:off x="11780215" y="6355080"/>
+            <a:ext cx="384048" cy="411480"/>
           </a:xfrm>
           <a:prstGeom prst="rect">
             <a:avLst/>
@@ -3952,7 +3949,7 @@
           </a:bodyPr>
           <a:lstStyle/>
           <a:p>
-            <a:pPr algn="l"/>
+            <a:pPr algn="ctr"/>
             <a:r>
               <a:rPr sz="1100" b="1" i="0">
                 <a:solidFill>
@@ -3987,7 +3984,7 @@
           </a:bodyPr>
           <a:lstStyle/>
           <a:p>
-            <a:pPr algn="l"/>
+            <a:pPr algn="ctr"/>
             <a:r>
               <a:rPr sz="2600" b="1" i="0">
                 <a:solidFill>
@@ -4928,7 +4925,7 @@
           </a:bodyPr>
           <a:lstStyle/>
           <a:p>
-            <a:pPr algn="l"/>
+            <a:pPr algn="ctr"/>
             <a:r>
               <a:rPr sz="1100" b="1" i="0">
                 <a:solidFill>
@@ -4963,7 +4960,7 @@
           </a:bodyPr>
           <a:lstStyle/>
           <a:p>
-            <a:pPr algn="l"/>
+            <a:pPr algn="ctr"/>
             <a:r>
               <a:rPr sz="950" b="0" i="0">
                 <a:solidFill>
@@ -5045,7 +5042,7 @@
           </a:bodyPr>
           <a:lstStyle/>
           <a:p>
-            <a:pPr algn="l"/>
+            <a:pPr algn="ctr"/>
             <a:r>
               <a:rPr sz="1100" b="1" i="0">
                 <a:solidFill>
@@ -5080,7 +5077,7 @@
           </a:bodyPr>
           <a:lstStyle/>
           <a:p>
-            <a:pPr algn="l"/>
+            <a:pPr algn="ctr"/>
             <a:r>
               <a:rPr sz="950" b="0" i="0">
                 <a:solidFill>
@@ -5161,7 +5158,7 @@
           </a:bodyPr>
           <a:lstStyle/>
           <a:p>
-            <a:pPr algn="l"/>
+            <a:pPr algn="ctr"/>
             <a:r>
               <a:rPr sz="1100" b="1" i="0">
                 <a:solidFill>
@@ -5196,7 +5193,7 @@
           </a:bodyPr>
           <a:lstStyle/>
           <a:p>
-            <a:pPr algn="l"/>
+            <a:pPr algn="ctr"/>
             <a:r>
               <a:rPr sz="950" b="0" i="0">
                 <a:solidFill>
@@ -5277,7 +5274,7 @@
           </a:bodyPr>
           <a:lstStyle/>
           <a:p>
-            <a:pPr algn="l"/>
+            <a:pPr algn="ctr"/>
             <a:r>
               <a:rPr sz="1100" b="1" i="0">
                 <a:solidFill>
@@ -5312,7 +5309,7 @@
           </a:bodyPr>
           <a:lstStyle/>
           <a:p>
-            <a:pPr algn="l"/>
+            <a:pPr algn="ctr"/>
             <a:r>
               <a:rPr sz="950" b="0" i="0">
                 <a:solidFill>
@@ -5437,7 +5434,7 @@
           </a:bodyPr>
           <a:lstStyle/>
           <a:p>
-            <a:pPr algn="l"/>
+            <a:pPr algn="ctr"/>
             <a:r>
               <a:rPr sz="1200" b="1" i="0">
                 <a:solidFill>
@@ -5518,7 +5515,7 @@
           </a:bodyPr>
           <a:lstStyle/>
           <a:p>
-            <a:pPr algn="l"/>
+            <a:pPr algn="ctr"/>
             <a:r>
               <a:rPr sz="1100" b="1" i="0">
                 <a:solidFill>
@@ -5553,7 +5550,7 @@
           </a:bodyPr>
           <a:lstStyle/>
           <a:p>
-            <a:pPr algn="l"/>
+            <a:pPr algn="ctr"/>
             <a:r>
               <a:rPr sz="950" b="0" i="0">
                 <a:solidFill>
@@ -5634,7 +5631,7 @@
           </a:bodyPr>
           <a:lstStyle/>
           <a:p>
-            <a:pPr algn="l"/>
+            <a:pPr algn="ctr"/>
             <a:r>
               <a:rPr sz="1100" b="1" i="0">
                 <a:solidFill>
@@ -5669,7 +5666,7 @@
           </a:bodyPr>
           <a:lstStyle/>
           <a:p>
-            <a:pPr algn="l"/>
+            <a:pPr algn="ctr"/>
             <a:r>
               <a:rPr sz="950" b="0" i="0">
                 <a:solidFill>
@@ -5750,7 +5747,7 @@
           </a:bodyPr>
           <a:lstStyle/>
           <a:p>
-            <a:pPr algn="l"/>
+            <a:pPr algn="ctr"/>
             <a:r>
               <a:rPr sz="1100" b="1" i="0">
                 <a:solidFill>
@@ -5785,7 +5782,7 @@
           </a:bodyPr>
           <a:lstStyle/>
           <a:p>
-            <a:pPr algn="l"/>
+            <a:pPr algn="ctr"/>
             <a:r>
               <a:rPr sz="950" b="0" i="0">
                 <a:solidFill>
@@ -5866,7 +5863,7 @@
           </a:bodyPr>
           <a:lstStyle/>
           <a:p>
-            <a:pPr algn="l"/>
+            <a:pPr algn="ctr"/>
             <a:r>
               <a:rPr sz="1100" b="1" i="0">
                 <a:solidFill>
@@ -5901,7 +5898,7 @@
           </a:bodyPr>
           <a:lstStyle/>
           <a:p>
-            <a:pPr algn="l"/>
+            <a:pPr algn="ctr"/>
             <a:r>
               <a:rPr sz="950" b="0" i="0">
                 <a:solidFill>
@@ -6129,7 +6126,7 @@
           </a:bodyPr>
           <a:lstStyle/>
           <a:p>
-            <a:pPr algn="l"/>
+            <a:pPr algn="ctr"/>
             <a:r>
               <a:rPr sz="1100" b="1" i="0">
                 <a:solidFill>
@@ -6164,7 +6161,7 @@
           </a:bodyPr>
           <a:lstStyle/>
           <a:p>
-            <a:pPr algn="l"/>
+            <a:pPr algn="ctr"/>
             <a:r>
               <a:rPr sz="2800" b="1" i="0">
                 <a:solidFill>
@@ -6368,7 +6365,7 @@
           </a:bodyPr>
           <a:lstStyle/>
           <a:p>
-            <a:pPr algn="l"/>
+            <a:pPr algn="ctr"/>
             <a:r>
               <a:rPr sz="1050" b="1" i="0">
                 <a:solidFill>
@@ -6403,7 +6400,7 @@
           </a:bodyPr>
           <a:lstStyle/>
           <a:p>
-            <a:pPr algn="l"/>
+            <a:pPr algn="ctr"/>
             <a:r>
               <a:rPr sz="880" b="0" i="0">
                 <a:solidFill>
@@ -6563,7 +6560,7 @@
           </a:bodyPr>
           <a:lstStyle/>
           <a:p>
-            <a:pPr algn="l"/>
+            <a:pPr algn="ctr"/>
             <a:r>
               <a:rPr sz="1050" b="1" i="0">
                 <a:solidFill>
@@ -6598,7 +6595,7 @@
           </a:bodyPr>
           <a:lstStyle/>
           <a:p>
-            <a:pPr algn="l"/>
+            <a:pPr algn="ctr"/>
             <a:r>
               <a:rPr sz="880" b="0" i="0">
                 <a:solidFill>
@@ -6758,7 +6755,7 @@
           </a:bodyPr>
           <a:lstStyle/>
           <a:p>
-            <a:pPr algn="l"/>
+            <a:pPr algn="ctr"/>
             <a:r>
               <a:rPr sz="1050" b="1" i="0">
                 <a:solidFill>
@@ -6793,7 +6790,7 @@
           </a:bodyPr>
           <a:lstStyle/>
           <a:p>
-            <a:pPr algn="l"/>
+            <a:pPr algn="ctr"/>
             <a:r>
               <a:rPr sz="880" b="0" i="0">
                 <a:solidFill>
@@ -6953,7 +6950,7 @@
           </a:bodyPr>
           <a:lstStyle/>
           <a:p>
-            <a:pPr algn="l"/>
+            <a:pPr algn="ctr"/>
             <a:r>
               <a:rPr sz="1050" b="1" i="0">
                 <a:solidFill>
@@ -6988,7 +6985,7 @@
           </a:bodyPr>
           <a:lstStyle/>
           <a:p>
-            <a:pPr algn="l"/>
+            <a:pPr algn="ctr"/>
             <a:r>
               <a:rPr sz="880" b="0" i="0">
                 <a:solidFill>
@@ -7148,7 +7145,7 @@
           </a:bodyPr>
           <a:lstStyle/>
           <a:p>
-            <a:pPr algn="l"/>
+            <a:pPr algn="ctr"/>
             <a:r>
               <a:rPr sz="1050" b="1" i="0">
                 <a:solidFill>
@@ -7183,7 +7180,7 @@
           </a:bodyPr>
           <a:lstStyle/>
           <a:p>
-            <a:pPr algn="l"/>
+            <a:pPr algn="ctr"/>
             <a:r>
               <a:rPr sz="880" b="0" i="0">
                 <a:solidFill>
@@ -7343,7 +7340,7 @@
           </a:bodyPr>
           <a:lstStyle/>
           <a:p>
-            <a:pPr algn="l"/>
+            <a:pPr algn="ctr"/>
             <a:r>
               <a:rPr sz="1050" b="1" i="0">
                 <a:solidFill>
@@ -7378,7 +7375,7 @@
           </a:bodyPr>
           <a:lstStyle/>
           <a:p>
-            <a:pPr algn="l"/>
+            <a:pPr algn="ctr"/>
             <a:r>
               <a:rPr sz="880" b="0" i="0">
                 <a:solidFill>
@@ -7538,7 +7535,7 @@
           </a:bodyPr>
           <a:lstStyle/>
           <a:p>
-            <a:pPr algn="l"/>
+            <a:pPr algn="ctr"/>
             <a:r>
               <a:rPr sz="1050" b="1" i="0">
                 <a:solidFill>
@@ -7573,7 +7570,7 @@
           </a:bodyPr>
           <a:lstStyle/>
           <a:p>
-            <a:pPr algn="l"/>
+            <a:pPr algn="ctr"/>
             <a:r>
               <a:rPr sz="880" b="0" i="0">
                 <a:solidFill>
@@ -7733,7 +7730,7 @@
           </a:bodyPr>
           <a:lstStyle/>
           <a:p>
-            <a:pPr algn="l"/>
+            <a:pPr algn="ctr"/>
             <a:r>
               <a:rPr sz="1050" b="1" i="0">
                 <a:solidFill>
@@ -7768,7 +7765,7 @@
           </a:bodyPr>
           <a:lstStyle/>
           <a:p>
-            <a:pPr algn="l"/>
+            <a:pPr algn="ctr"/>
             <a:r>
               <a:rPr sz="880" b="0" i="0">
                 <a:solidFill>
@@ -7928,7 +7925,7 @@
           </a:bodyPr>
           <a:lstStyle/>
           <a:p>
-            <a:pPr algn="l"/>
+            <a:pPr algn="ctr"/>
             <a:r>
               <a:rPr sz="1050" b="1" i="0">
                 <a:solidFill>
@@ -7963,7 +7960,7 @@
           </a:bodyPr>
           <a:lstStyle/>
           <a:p>
-            <a:pPr algn="l"/>
+            <a:pPr algn="ctr"/>
             <a:r>
               <a:rPr sz="880" b="0" i="0">
                 <a:solidFill>
@@ -8123,7 +8120,7 @@
           </a:bodyPr>
           <a:lstStyle/>
           <a:p>
-            <a:pPr algn="l"/>
+            <a:pPr algn="ctr"/>
             <a:r>
               <a:rPr sz="1050" b="1" i="0">
                 <a:solidFill>
@@ -8158,7 +8155,7 @@
           </a:bodyPr>
           <a:lstStyle/>
           <a:p>
-            <a:pPr algn="l"/>
+            <a:pPr algn="ctr"/>
             <a:r>
               <a:rPr sz="880" b="0" i="0">
                 <a:solidFill>
@@ -8318,7 +8315,7 @@
           </a:bodyPr>
           <a:lstStyle/>
           <a:p>
-            <a:pPr algn="l"/>
+            <a:pPr algn="ctr"/>
             <a:r>
               <a:rPr sz="1050" b="1" i="0">
                 <a:solidFill>
@@ -8353,7 +8350,7 @@
           </a:bodyPr>
           <a:lstStyle/>
           <a:p>
-            <a:pPr algn="l"/>
+            <a:pPr algn="ctr"/>
             <a:r>
               <a:rPr sz="880" b="0" i="0">
                 <a:solidFill>
@@ -8513,7 +8510,7 @@
           </a:bodyPr>
           <a:lstStyle/>
           <a:p>
-            <a:pPr algn="l"/>
+            <a:pPr algn="ctr"/>
             <a:r>
               <a:rPr sz="1050" b="1" i="0">
                 <a:solidFill>
@@ -8548,7 +8545,7 @@
           </a:bodyPr>
           <a:lstStyle/>
           <a:p>
-            <a:pPr algn="l"/>
+            <a:pPr algn="ctr"/>
             <a:r>
               <a:rPr sz="880" b="0" i="0">
                 <a:solidFill>
@@ -8673,7 +8670,7 @@
           </a:bodyPr>
           <a:lstStyle/>
           <a:p>
-            <a:pPr algn="l"/>
+            <a:pPr algn="ctr"/>
             <a:r>
               <a:rPr sz="1300" b="0" i="1">
                 <a:solidFill>
@@ -8901,7 +8898,7 @@
           </a:bodyPr>
           <a:lstStyle/>
           <a:p>
-            <a:pPr algn="l"/>
+            <a:pPr algn="ctr"/>
             <a:r>
               <a:rPr sz="1100" b="1" i="0">
                 <a:solidFill>
@@ -8936,7 +8933,7 @@
           </a:bodyPr>
           <a:lstStyle/>
           <a:p>
-            <a:pPr algn="l"/>
+            <a:pPr algn="ctr"/>
             <a:r>
               <a:rPr sz="2600" b="1" i="0">
                 <a:solidFill>
@@ -9140,7 +9137,7 @@
           </a:bodyPr>
           <a:lstStyle/>
           <a:p>
-            <a:pPr algn="l"/>
+            <a:pPr algn="ctr"/>
             <a:r>
               <a:rPr sz="1150" b="1" i="0">
                 <a:solidFill>
@@ -9175,7 +9172,7 @@
           </a:bodyPr>
           <a:lstStyle/>
           <a:p>
-            <a:pPr algn="l"/>
+            <a:pPr algn="ctr"/>
             <a:r>
               <a:rPr sz="850" b="0" i="1">
                 <a:solidFill>
@@ -9210,7 +9207,7 @@
           </a:bodyPr>
           <a:lstStyle/>
           <a:p>
-            <a:pPr algn="l"/>
+            <a:pPr algn="ctr"/>
             <a:r>
               <a:rPr sz="850" b="0" i="0">
                 <a:solidFill>
@@ -9290,7 +9287,7 @@
           </a:bodyPr>
           <a:lstStyle/>
           <a:p>
-            <a:pPr algn="l"/>
+            <a:pPr algn="ctr"/>
             <a:r>
               <a:rPr sz="800" b="1" i="0">
                 <a:solidFill>
@@ -9450,7 +9447,7 @@
           </a:bodyPr>
           <a:lstStyle/>
           <a:p>
-            <a:pPr algn="l"/>
+            <a:pPr algn="ctr"/>
             <a:r>
               <a:rPr sz="1150" b="1" i="0">
                 <a:solidFill>
@@ -9485,7 +9482,7 @@
           </a:bodyPr>
           <a:lstStyle/>
           <a:p>
-            <a:pPr algn="l"/>
+            <a:pPr algn="ctr"/>
             <a:r>
               <a:rPr sz="850" b="0" i="1">
                 <a:solidFill>
@@ -9520,7 +9517,7 @@
           </a:bodyPr>
           <a:lstStyle/>
           <a:p>
-            <a:pPr algn="l"/>
+            <a:pPr algn="ctr"/>
             <a:r>
               <a:rPr sz="850" b="0" i="0">
                 <a:solidFill>
@@ -9600,7 +9597,7 @@
           </a:bodyPr>
           <a:lstStyle/>
           <a:p>
-            <a:pPr algn="l"/>
+            <a:pPr algn="ctr"/>
             <a:r>
               <a:rPr sz="800" b="1" i="0">
                 <a:solidFill>
@@ -9760,7 +9757,7 @@
           </a:bodyPr>
           <a:lstStyle/>
           <a:p>
-            <a:pPr algn="l"/>
+            <a:pPr algn="ctr"/>
             <a:r>
               <a:rPr sz="1150" b="1" i="0">
                 <a:solidFill>
@@ -9795,7 +9792,7 @@
           </a:bodyPr>
           <a:lstStyle/>
           <a:p>
-            <a:pPr algn="l"/>
+            <a:pPr algn="ctr"/>
             <a:r>
               <a:rPr sz="850" b="0" i="1">
                 <a:solidFill>
@@ -9830,7 +9827,7 @@
           </a:bodyPr>
           <a:lstStyle/>
           <a:p>
-            <a:pPr algn="l"/>
+            <a:pPr algn="ctr"/>
             <a:r>
               <a:rPr sz="850" b="0" i="0">
                 <a:solidFill>
@@ -9910,7 +9907,7 @@
           </a:bodyPr>
           <a:lstStyle/>
           <a:p>
-            <a:pPr algn="l"/>
+            <a:pPr algn="ctr"/>
             <a:r>
               <a:rPr sz="800" b="1" i="0">
                 <a:solidFill>
@@ -10070,7 +10067,7 @@
           </a:bodyPr>
           <a:lstStyle/>
           <a:p>
-            <a:pPr algn="l"/>
+            <a:pPr algn="ctr"/>
             <a:r>
               <a:rPr sz="1150" b="1" i="0">
                 <a:solidFill>
@@ -10105,7 +10102,7 @@
           </a:bodyPr>
           <a:lstStyle/>
           <a:p>
-            <a:pPr algn="l"/>
+            <a:pPr algn="ctr"/>
             <a:r>
               <a:rPr sz="850" b="0" i="1">
                 <a:solidFill>
@@ -10140,7 +10137,7 @@
           </a:bodyPr>
           <a:lstStyle/>
           <a:p>
-            <a:pPr algn="l"/>
+            <a:pPr algn="ctr"/>
             <a:r>
               <a:rPr sz="850" b="0" i="0">
                 <a:solidFill>
@@ -10220,7 +10217,7 @@
           </a:bodyPr>
           <a:lstStyle/>
           <a:p>
-            <a:pPr algn="l"/>
+            <a:pPr algn="ctr"/>
             <a:r>
               <a:rPr sz="800" b="1" i="0">
                 <a:solidFill>
@@ -10380,7 +10377,7 @@
           </a:bodyPr>
           <a:lstStyle/>
           <a:p>
-            <a:pPr algn="l"/>
+            <a:pPr algn="ctr"/>
             <a:r>
               <a:rPr sz="1150" b="1" i="0">
                 <a:solidFill>
@@ -10415,7 +10412,7 @@
           </a:bodyPr>
           <a:lstStyle/>
           <a:p>
-            <a:pPr algn="l"/>
+            <a:pPr algn="ctr"/>
             <a:r>
               <a:rPr sz="850" b="0" i="1">
                 <a:solidFill>
@@ -10450,7 +10447,7 @@
           </a:bodyPr>
           <a:lstStyle/>
           <a:p>
-            <a:pPr algn="l"/>
+            <a:pPr algn="ctr"/>
             <a:r>
               <a:rPr sz="850" b="0" i="0">
                 <a:solidFill>
@@ -10530,7 +10527,7 @@
           </a:bodyPr>
           <a:lstStyle/>
           <a:p>
-            <a:pPr algn="l"/>
+            <a:pPr algn="ctr"/>
             <a:r>
               <a:rPr sz="800" b="1" i="0">
                 <a:solidFill>
@@ -10611,7 +10608,7 @@
           </a:bodyPr>
           <a:lstStyle/>
           <a:p>
-            <a:pPr algn="l"/>
+            <a:pPr algn="ctr"/>
             <a:r>
               <a:rPr sz="1000" b="1" i="0">
                 <a:solidFill>
@@ -10771,7 +10768,7 @@
           </a:bodyPr>
           <a:lstStyle/>
           <a:p>
-            <a:pPr algn="l"/>
+            <a:pPr algn="ctr"/>
             <a:r>
               <a:rPr sz="1300" b="1" i="0">
                 <a:solidFill>
@@ -10806,7 +10803,7 @@
           </a:bodyPr>
           <a:lstStyle/>
           <a:p>
-            <a:pPr algn="l"/>
+            <a:pPr algn="ctr"/>
             <a:r>
               <a:rPr sz="850" b="0" i="1">
                 <a:solidFill>
@@ -10841,7 +10838,7 @@
           </a:bodyPr>
           <a:lstStyle/>
           <a:p>
-            <a:pPr algn="l"/>
+            <a:pPr algn="ctr"/>
             <a:r>
               <a:rPr sz="900" b="0" i="0">
                 <a:solidFill>
@@ -10921,7 +10918,7 @@
           </a:bodyPr>
           <a:lstStyle/>
           <a:p>
-            <a:pPr algn="l"/>
+            <a:pPr algn="ctr"/>
             <a:r>
               <a:rPr sz="850" b="1" i="0">
                 <a:solidFill>
@@ -11081,7 +11078,7 @@
           </a:bodyPr>
           <a:lstStyle/>
           <a:p>
-            <a:pPr algn="l"/>
+            <a:pPr algn="ctr"/>
             <a:r>
               <a:rPr sz="1300" b="1" i="0">
                 <a:solidFill>
@@ -11116,7 +11113,7 @@
           </a:bodyPr>
           <a:lstStyle/>
           <a:p>
-            <a:pPr algn="l"/>
+            <a:pPr algn="ctr"/>
             <a:r>
               <a:rPr sz="850" b="0" i="1">
                 <a:solidFill>
@@ -11151,7 +11148,7 @@
           </a:bodyPr>
           <a:lstStyle/>
           <a:p>
-            <a:pPr algn="l"/>
+            <a:pPr algn="ctr"/>
             <a:r>
               <a:rPr sz="900" b="0" i="0">
                 <a:solidFill>
@@ -11231,7 +11228,7 @@
           </a:bodyPr>
           <a:lstStyle/>
           <a:p>
-            <a:pPr algn="l"/>
+            <a:pPr algn="ctr"/>
             <a:r>
               <a:rPr sz="850" b="1" i="0">
                 <a:solidFill>
@@ -11391,7 +11388,7 @@
           </a:bodyPr>
           <a:lstStyle/>
           <a:p>
-            <a:pPr algn="l"/>
+            <a:pPr algn="ctr"/>
             <a:r>
               <a:rPr sz="1300" b="1" i="0">
                 <a:solidFill>
@@ -11426,7 +11423,7 @@
           </a:bodyPr>
           <a:lstStyle/>
           <a:p>
-            <a:pPr algn="l"/>
+            <a:pPr algn="ctr"/>
             <a:r>
               <a:rPr sz="850" b="0" i="1">
                 <a:solidFill>
@@ -11461,7 +11458,7 @@
           </a:bodyPr>
           <a:lstStyle/>
           <a:p>
-            <a:pPr algn="l"/>
+            <a:pPr algn="ctr"/>
             <a:r>
               <a:rPr sz="900" b="0" i="0">
                 <a:solidFill>
@@ -11541,7 +11538,7 @@
           </a:bodyPr>
           <a:lstStyle/>
           <a:p>
-            <a:pPr algn="l"/>
+            <a:pPr algn="ctr"/>
             <a:r>
               <a:rPr sz="850" b="1" i="0">
                 <a:solidFill>
@@ -11664,7 +11661,7 @@
           </a:bodyPr>
           <a:lstStyle/>
           <a:p>
-            <a:pPr algn="l"/>
+            <a:pPr algn="ctr"/>
             <a:r>
               <a:rPr sz="1000" b="1" i="0">
                 <a:solidFill>
@@ -11922,8 +11919,8 @@
         </p:nvSpPr>
         <p:spPr>
           <a:xfrm>
-            <a:off x="274320" y="91440"/>
-            <a:ext cx="5486400" cy="320040"/>
+            <a:off x="274320" y="64008"/>
+            <a:ext cx="7315200" cy="237744"/>
           </a:xfrm>
           <a:prstGeom prst="rect">
             <a:avLst/>
@@ -11938,7 +11935,7 @@
           <a:p>
             <a:pPr algn="l"/>
             <a:r>
-              <a:rPr sz="1100" b="1" i="0">
+              <a:rPr sz="1000" b="1" i="0">
                 <a:solidFill>
                   <a:srgbClr val="FF4545"/>
                 </a:solidFill>
@@ -11957,8 +11954,8 @@
         </p:nvSpPr>
         <p:spPr>
           <a:xfrm>
-            <a:off x="274320" y="411480"/>
-            <a:ext cx="10972800" cy="685800"/>
+            <a:off x="274320" y="292608"/>
+            <a:ext cx="11430000" cy="475488"/>
           </a:xfrm>
           <a:prstGeom prst="rect">
             <a:avLst/>
@@ -11973,7 +11970,7 @@
           <a:p>
             <a:pPr algn="l"/>
             <a:r>
-              <a:rPr sz="3600" b="1" i="0">
+              <a:rPr sz="3400" b="1" i="0">
                 <a:solidFill>
                   <a:srgbClr val="FFFFFF"/>
                 </a:solidFill>
@@ -11992,51 +11989,7 @@
         </p:nvSpPr>
         <p:spPr>
           <a:xfrm>
-            <a:off x="274320" y="1115568"/>
-            <a:ext cx="5486400" cy="32004"/>
-          </a:xfrm>
-          <a:prstGeom prst="rect">
-            <a:avLst/>
-          </a:prstGeom>
-          <a:solidFill>
-            <a:srgbClr val="FF4545"/>
-          </a:solidFill>
-          <a:ln>
-            <a:noFill/>
-          </a:ln>
-          <a:effectLst/>
-        </p:spPr>
-        <p:style>
-          <a:lnRef idx="1">
-            <a:schemeClr val="accent1"/>
-          </a:lnRef>
-          <a:fillRef idx="3">
-            <a:schemeClr val="accent1"/>
-          </a:fillRef>
-          <a:effectRef idx="2">
-            <a:schemeClr val="accent1"/>
-          </a:effectRef>
-          <a:fontRef idx="minor">
-            <a:schemeClr val="lt1"/>
-          </a:fontRef>
-        </p:style>
-        <p:txBody>
-          <a:bodyPr rtlCol="0" anchor="ctr"/>
-          <a:lstStyle/>
-          <a:p>
-            <a:pPr algn="ctr"/>
-          </a:p>
-        </p:txBody>
-      </p:sp>
-      <p:sp>
-        <p:nvSpPr>
-          <p:cNvPr id="8" name="Rectangle 7"/>
-          <p:cNvSpPr/>
-          <p:nvPr/>
-        </p:nvSpPr>
-        <p:spPr>
-          <a:xfrm>
-            <a:off x="274320" y="1325880"/>
+            <a:off x="274320" y="1207008"/>
             <a:ext cx="5303520" cy="1143000"/>
           </a:xfrm>
           <a:prstGeom prst="rect">
@@ -12076,14 +12029,49 @@
       </p:sp>
       <p:sp>
         <p:nvSpPr>
+          <p:cNvPr id="8" name="TextBox 7"/>
+          <p:cNvSpPr txBox="1"/>
+          <p:nvPr/>
+        </p:nvSpPr>
+        <p:spPr>
+          <a:xfrm>
+            <a:off x="384048" y="1298448"/>
+            <a:ext cx="365760" cy="457200"/>
+          </a:xfrm>
+          <a:prstGeom prst="rect">
+            <a:avLst/>
+          </a:prstGeom>
+          <a:noFill/>
+        </p:spPr>
+        <p:txBody>
+          <a:bodyPr wrap="square">
+            <a:spAutoFit/>
+          </a:bodyPr>
+          <a:lstStyle/>
+          <a:p>
+            <a:pPr algn="ctr"/>
+            <a:r>
+              <a:rPr sz="2000" b="1" i="0">
+                <a:solidFill>
+                  <a:srgbClr val="FF4545"/>
+                </a:solidFill>
+                <a:latin typeface="Calibri"/>
+              </a:rPr>
+              <a:t>✕</a:t>
+            </a:r>
+          </a:p>
+        </p:txBody>
+      </p:sp>
+      <p:sp>
+        <p:nvSpPr>
           <p:cNvPr id="9" name="TextBox 8"/>
           <p:cNvSpPr txBox="1"/>
           <p:nvPr/>
         </p:nvSpPr>
         <p:spPr>
           <a:xfrm>
-            <a:off x="384048" y="1417320"/>
-            <a:ext cx="365760" cy="457200"/>
+            <a:off x="713232" y="1280160"/>
+            <a:ext cx="4754880" cy="329184"/>
           </a:xfrm>
           <a:prstGeom prst="rect">
             <a:avLst/>
@@ -12098,13 +12086,13 @@
           <a:p>
             <a:pPr algn="l"/>
             <a:r>
-              <a:rPr sz="2000" b="1" i="0">
-                <a:solidFill>
-                  <a:srgbClr val="FF4545"/>
-                </a:solidFill>
-                <a:latin typeface="Calibri"/>
-              </a:rPr>
-              <a:t>✕</a:t>
+              <a:rPr sz="1400" b="1" i="0">
+                <a:solidFill>
+                  <a:srgbClr val="FFFFFF"/>
+                </a:solidFill>
+                <a:latin typeface="Calibri"/>
+              </a:rPr>
+              <a:t>No Structured World Model</a:t>
             </a:r>
           </a:p>
         </p:txBody>
@@ -12117,8 +12105,8 @@
         </p:nvSpPr>
         <p:spPr>
           <a:xfrm>
-            <a:off x="713232" y="1399032"/>
-            <a:ext cx="4754880" cy="347472"/>
+            <a:off x="713232" y="1609344"/>
+            <a:ext cx="4754880" cy="658368"/>
           </a:xfrm>
           <a:prstGeom prst="rect">
             <a:avLst/>
@@ -12133,41 +12121,6 @@
           <a:p>
             <a:pPr algn="l"/>
             <a:r>
-              <a:rPr sz="1400" b="1" i="0">
-                <a:solidFill>
-                  <a:srgbClr val="FFFFFF"/>
-                </a:solidFill>
-                <a:latin typeface="Calibri"/>
-              </a:rPr>
-              <a:t>No Structured World Model</a:t>
-            </a:r>
-          </a:p>
-        </p:txBody>
-      </p:sp>
-      <p:sp>
-        <p:nvSpPr>
-          <p:cNvPr id="11" name="TextBox 10"/>
-          <p:cNvSpPr txBox="1"/>
-          <p:nvPr/>
-        </p:nvSpPr>
-        <p:spPr>
-          <a:xfrm>
-            <a:off x="713232" y="1728216"/>
-            <a:ext cx="4754880" cy="658368"/>
-          </a:xfrm>
-          <a:prstGeom prst="rect">
-            <a:avLst/>
-          </a:prstGeom>
-          <a:noFill/>
-        </p:spPr>
-        <p:txBody>
-          <a:bodyPr wrap="square">
-            <a:spAutoFit/>
-          </a:bodyPr>
-          <a:lstStyle/>
-          <a:p>
-            <a:pPr algn="l"/>
-            <a:r>
               <a:rPr sz="1150" b="0" i="0">
                 <a:solidFill>
                   <a:srgbClr val="A0AAB8"/>
@@ -12181,13 +12134,13 @@
       </p:sp>
       <p:sp>
         <p:nvSpPr>
-          <p:cNvPr id="12" name="Rectangle 11"/>
+          <p:cNvPr id="11" name="Rectangle 10"/>
           <p:cNvSpPr/>
           <p:nvPr/>
         </p:nvSpPr>
         <p:spPr>
           <a:xfrm>
-            <a:off x="274320" y="2560320"/>
+            <a:off x="274320" y="2441448"/>
             <a:ext cx="5303520" cy="1143000"/>
           </a:xfrm>
           <a:prstGeom prst="rect">
@@ -12227,14 +12180,49 @@
       </p:sp>
       <p:sp>
         <p:nvSpPr>
+          <p:cNvPr id="12" name="TextBox 11"/>
+          <p:cNvSpPr txBox="1"/>
+          <p:nvPr/>
+        </p:nvSpPr>
+        <p:spPr>
+          <a:xfrm>
+            <a:off x="384048" y="2532888"/>
+            <a:ext cx="365760" cy="457200"/>
+          </a:xfrm>
+          <a:prstGeom prst="rect">
+            <a:avLst/>
+          </a:prstGeom>
+          <a:noFill/>
+        </p:spPr>
+        <p:txBody>
+          <a:bodyPr wrap="square">
+            <a:spAutoFit/>
+          </a:bodyPr>
+          <a:lstStyle/>
+          <a:p>
+            <a:pPr algn="ctr"/>
+            <a:r>
+              <a:rPr sz="2000" b="1" i="0">
+                <a:solidFill>
+                  <a:srgbClr val="FF4545"/>
+                </a:solidFill>
+                <a:latin typeface="Calibri"/>
+              </a:rPr>
+              <a:t>✕</a:t>
+            </a:r>
+          </a:p>
+        </p:txBody>
+      </p:sp>
+      <p:sp>
+        <p:nvSpPr>
           <p:cNvPr id="13" name="TextBox 12"/>
           <p:cNvSpPr txBox="1"/>
           <p:nvPr/>
         </p:nvSpPr>
         <p:spPr>
           <a:xfrm>
-            <a:off x="384048" y="2651760"/>
-            <a:ext cx="365760" cy="457200"/>
+            <a:off x="713232" y="2514600"/>
+            <a:ext cx="4754880" cy="329184"/>
           </a:xfrm>
           <a:prstGeom prst="rect">
             <a:avLst/>
@@ -12249,13 +12237,13 @@
           <a:p>
             <a:pPr algn="l"/>
             <a:r>
-              <a:rPr sz="2000" b="1" i="0">
-                <a:solidFill>
-                  <a:srgbClr val="FF4545"/>
-                </a:solidFill>
-                <a:latin typeface="Calibri"/>
-              </a:rPr>
-              <a:t>✕</a:t>
+              <a:rPr sz="1400" b="1" i="0">
+                <a:solidFill>
+                  <a:srgbClr val="FFFFFF"/>
+                </a:solidFill>
+                <a:latin typeface="Calibri"/>
+              </a:rPr>
+              <a:t>No Attack Path Reasoning</a:t>
             </a:r>
           </a:p>
         </p:txBody>
@@ -12268,8 +12256,8 @@
         </p:nvSpPr>
         <p:spPr>
           <a:xfrm>
-            <a:off x="713232" y="2633472"/>
-            <a:ext cx="4754880" cy="347472"/>
+            <a:off x="713232" y="2843784"/>
+            <a:ext cx="4754880" cy="658368"/>
           </a:xfrm>
           <a:prstGeom prst="rect">
             <a:avLst/>
@@ -12284,41 +12272,6 @@
           <a:p>
             <a:pPr algn="l"/>
             <a:r>
-              <a:rPr sz="1400" b="1" i="0">
-                <a:solidFill>
-                  <a:srgbClr val="FFFFFF"/>
-                </a:solidFill>
-                <a:latin typeface="Calibri"/>
-              </a:rPr>
-              <a:t>No Attack Path Reasoning</a:t>
-            </a:r>
-          </a:p>
-        </p:txBody>
-      </p:sp>
-      <p:sp>
-        <p:nvSpPr>
-          <p:cNvPr id="15" name="TextBox 14"/>
-          <p:cNvSpPr txBox="1"/>
-          <p:nvPr/>
-        </p:nvSpPr>
-        <p:spPr>
-          <a:xfrm>
-            <a:off x="713232" y="2962656"/>
-            <a:ext cx="4754880" cy="658368"/>
-          </a:xfrm>
-          <a:prstGeom prst="rect">
-            <a:avLst/>
-          </a:prstGeom>
-          <a:noFill/>
-        </p:spPr>
-        <p:txBody>
-          <a:bodyPr wrap="square">
-            <a:spAutoFit/>
-          </a:bodyPr>
-          <a:lstStyle/>
-          <a:p>
-            <a:pPr algn="l"/>
-            <a:r>
               <a:rPr sz="1150" b="0" i="0">
                 <a:solidFill>
                   <a:srgbClr val="A0AAB8"/>
@@ -12332,13 +12285,13 @@
       </p:sp>
       <p:sp>
         <p:nvSpPr>
-          <p:cNvPr id="16" name="Rectangle 15"/>
+          <p:cNvPr id="15" name="Rectangle 14"/>
           <p:cNvSpPr/>
           <p:nvPr/>
         </p:nvSpPr>
         <p:spPr>
           <a:xfrm>
-            <a:off x="274320" y="3794760"/>
+            <a:off x="274320" y="3675888"/>
             <a:ext cx="5303520" cy="1143000"/>
           </a:xfrm>
           <a:prstGeom prst="rect">
@@ -12378,14 +12331,49 @@
       </p:sp>
       <p:sp>
         <p:nvSpPr>
+          <p:cNvPr id="16" name="TextBox 15"/>
+          <p:cNvSpPr txBox="1"/>
+          <p:nvPr/>
+        </p:nvSpPr>
+        <p:spPr>
+          <a:xfrm>
+            <a:off x="384048" y="3767328"/>
+            <a:ext cx="365760" cy="457200"/>
+          </a:xfrm>
+          <a:prstGeom prst="rect">
+            <a:avLst/>
+          </a:prstGeom>
+          <a:noFill/>
+        </p:spPr>
+        <p:txBody>
+          <a:bodyPr wrap="square">
+            <a:spAutoFit/>
+          </a:bodyPr>
+          <a:lstStyle/>
+          <a:p>
+            <a:pPr algn="ctr"/>
+            <a:r>
+              <a:rPr sz="2000" b="1" i="0">
+                <a:solidFill>
+                  <a:srgbClr val="FF4545"/>
+                </a:solidFill>
+                <a:latin typeface="Calibri"/>
+              </a:rPr>
+              <a:t>✕</a:t>
+            </a:r>
+          </a:p>
+        </p:txBody>
+      </p:sp>
+      <p:sp>
+        <p:nvSpPr>
           <p:cNvPr id="17" name="TextBox 16"/>
           <p:cNvSpPr txBox="1"/>
           <p:nvPr/>
         </p:nvSpPr>
         <p:spPr>
           <a:xfrm>
-            <a:off x="384048" y="3886200"/>
-            <a:ext cx="365760" cy="457200"/>
+            <a:off x="713232" y="3749040"/>
+            <a:ext cx="4754880" cy="329184"/>
           </a:xfrm>
           <a:prstGeom prst="rect">
             <a:avLst/>
@@ -12400,13 +12388,13 @@
           <a:p>
             <a:pPr algn="l"/>
             <a:r>
-              <a:rPr sz="2000" b="1" i="0">
-                <a:solidFill>
-                  <a:srgbClr val="FF4545"/>
-                </a:solidFill>
-                <a:latin typeface="Calibri"/>
-              </a:rPr>
-              <a:t>✕</a:t>
+              <a:rPr sz="1400" b="1" i="0">
+                <a:solidFill>
+                  <a:srgbClr val="FFFFFF"/>
+                </a:solidFill>
+                <a:latin typeface="Calibri"/>
+              </a:rPr>
+              <a:t>Fragile Re-Planning</a:t>
             </a:r>
           </a:p>
         </p:txBody>
@@ -12419,8 +12407,8 @@
         </p:nvSpPr>
         <p:spPr>
           <a:xfrm>
-            <a:off x="713232" y="3867912"/>
-            <a:ext cx="4754880" cy="347472"/>
+            <a:off x="713232" y="4078224"/>
+            <a:ext cx="4754880" cy="658368"/>
           </a:xfrm>
           <a:prstGeom prst="rect">
             <a:avLst/>
@@ -12435,41 +12423,6 @@
           <a:p>
             <a:pPr algn="l"/>
             <a:r>
-              <a:rPr sz="1400" b="1" i="0">
-                <a:solidFill>
-                  <a:srgbClr val="FFFFFF"/>
-                </a:solidFill>
-                <a:latin typeface="Calibri"/>
-              </a:rPr>
-              <a:t>Fragile Re-Planning</a:t>
-            </a:r>
-          </a:p>
-        </p:txBody>
-      </p:sp>
-      <p:sp>
-        <p:nvSpPr>
-          <p:cNvPr id="19" name="TextBox 18"/>
-          <p:cNvSpPr txBox="1"/>
-          <p:nvPr/>
-        </p:nvSpPr>
-        <p:spPr>
-          <a:xfrm>
-            <a:off x="713232" y="4197096"/>
-            <a:ext cx="4754880" cy="658368"/>
-          </a:xfrm>
-          <a:prstGeom prst="rect">
-            <a:avLst/>
-          </a:prstGeom>
-          <a:noFill/>
-        </p:spPr>
-        <p:txBody>
-          <a:bodyPr wrap="square">
-            <a:spAutoFit/>
-          </a:bodyPr>
-          <a:lstStyle/>
-          <a:p>
-            <a:pPr algn="l"/>
-            <a:r>
               <a:rPr sz="1150" b="0" i="0">
                 <a:solidFill>
                   <a:srgbClr val="A0AAB8"/>
@@ -12483,13 +12436,13 @@
       </p:sp>
       <p:sp>
         <p:nvSpPr>
-          <p:cNvPr id="20" name="Rectangle 19"/>
+          <p:cNvPr id="19" name="Rectangle 18"/>
           <p:cNvSpPr/>
           <p:nvPr/>
         </p:nvSpPr>
         <p:spPr>
           <a:xfrm>
-            <a:off x="274320" y="5029200"/>
+            <a:off x="274320" y="4910328"/>
             <a:ext cx="5303520" cy="1143000"/>
           </a:xfrm>
           <a:prstGeom prst="rect">
@@ -12529,14 +12482,49 @@
       </p:sp>
       <p:sp>
         <p:nvSpPr>
+          <p:cNvPr id="20" name="TextBox 19"/>
+          <p:cNvSpPr txBox="1"/>
+          <p:nvPr/>
+        </p:nvSpPr>
+        <p:spPr>
+          <a:xfrm>
+            <a:off x="384048" y="5001768"/>
+            <a:ext cx="365760" cy="457200"/>
+          </a:xfrm>
+          <a:prstGeom prst="rect">
+            <a:avLst/>
+          </a:prstGeom>
+          <a:noFill/>
+        </p:spPr>
+        <p:txBody>
+          <a:bodyPr wrap="square">
+            <a:spAutoFit/>
+          </a:bodyPr>
+          <a:lstStyle/>
+          <a:p>
+            <a:pPr algn="ctr"/>
+            <a:r>
+              <a:rPr sz="2000" b="1" i="0">
+                <a:solidFill>
+                  <a:srgbClr val="FF4545"/>
+                </a:solidFill>
+                <a:latin typeface="Calibri"/>
+              </a:rPr>
+              <a:t>✕</a:t>
+            </a:r>
+          </a:p>
+        </p:txBody>
+      </p:sp>
+      <p:sp>
+        <p:nvSpPr>
           <p:cNvPr id="21" name="TextBox 20"/>
           <p:cNvSpPr txBox="1"/>
           <p:nvPr/>
         </p:nvSpPr>
         <p:spPr>
           <a:xfrm>
-            <a:off x="384048" y="5120640"/>
-            <a:ext cx="365760" cy="457200"/>
+            <a:off x="713232" y="4983480"/>
+            <a:ext cx="4754880" cy="329184"/>
           </a:xfrm>
           <a:prstGeom prst="rect">
             <a:avLst/>
@@ -12551,13 +12539,13 @@
           <a:p>
             <a:pPr algn="l"/>
             <a:r>
-              <a:rPr sz="2000" b="1" i="0">
-                <a:solidFill>
-                  <a:srgbClr val="FF4545"/>
-                </a:solidFill>
-                <a:latin typeface="Calibri"/>
-              </a:rPr>
-              <a:t>✕</a:t>
+              <a:rPr sz="1400" b="1" i="0">
+                <a:solidFill>
+                  <a:srgbClr val="FFFFFF"/>
+                </a:solidFill>
+                <a:latin typeface="Calibri"/>
+              </a:rPr>
+              <a:t>Arbitrary Termination</a:t>
             </a:r>
           </a:p>
         </p:txBody>
@@ -12570,8 +12558,8 @@
         </p:nvSpPr>
         <p:spPr>
           <a:xfrm>
-            <a:off x="713232" y="5102352"/>
-            <a:ext cx="4754880" cy="347472"/>
+            <a:off x="713232" y="5312664"/>
+            <a:ext cx="4754880" cy="658368"/>
           </a:xfrm>
           <a:prstGeom prst="rect">
             <a:avLst/>
@@ -12586,41 +12574,6 @@
           <a:p>
             <a:pPr algn="l"/>
             <a:r>
-              <a:rPr sz="1400" b="1" i="0">
-                <a:solidFill>
-                  <a:srgbClr val="FFFFFF"/>
-                </a:solidFill>
-                <a:latin typeface="Calibri"/>
-              </a:rPr>
-              <a:t>Arbitrary Termination</a:t>
-            </a:r>
-          </a:p>
-        </p:txBody>
-      </p:sp>
-      <p:sp>
-        <p:nvSpPr>
-          <p:cNvPr id="23" name="TextBox 22"/>
-          <p:cNvSpPr txBox="1"/>
-          <p:nvPr/>
-        </p:nvSpPr>
-        <p:spPr>
-          <a:xfrm>
-            <a:off x="713232" y="5431536"/>
-            <a:ext cx="4754880" cy="658368"/>
-          </a:xfrm>
-          <a:prstGeom prst="rect">
-            <a:avLst/>
-          </a:prstGeom>
-          <a:noFill/>
-        </p:spPr>
-        <p:txBody>
-          <a:bodyPr wrap="square">
-            <a:spAutoFit/>
-          </a:bodyPr>
-          <a:lstStyle/>
-          <a:p>
-            <a:pPr algn="l"/>
-            <a:r>
               <a:rPr sz="1150" b="0" i="0">
                 <a:solidFill>
                   <a:srgbClr val="A0AAB8"/>
@@ -12634,13 +12587,13 @@
       </p:sp>
       <p:sp>
         <p:nvSpPr>
-          <p:cNvPr id="24" name="Rectangle 23"/>
+          <p:cNvPr id="23" name="Rectangle 22"/>
           <p:cNvSpPr/>
           <p:nvPr/>
         </p:nvSpPr>
         <p:spPr>
           <a:xfrm>
-            <a:off x="5943600" y="1325880"/>
+            <a:off x="5943600" y="1207008"/>
             <a:ext cx="5943600" cy="2331720"/>
           </a:xfrm>
           <a:prstGeom prst="rect">
@@ -12680,48 +12633,48 @@
       </p:sp>
       <p:sp>
         <p:nvSpPr>
+          <p:cNvPr id="24" name="TextBox 23"/>
+          <p:cNvSpPr txBox="1"/>
+          <p:nvPr/>
+        </p:nvSpPr>
+        <p:spPr>
+          <a:xfrm>
+            <a:off x="6080760" y="1252728"/>
+            <a:ext cx="548640" cy="640080"/>
+          </a:xfrm>
+          <a:prstGeom prst="rect">
+            <a:avLst/>
+          </a:prstGeom>
+          <a:noFill/>
+        </p:spPr>
+        <p:txBody>
+          <a:bodyPr wrap="square">
+            <a:spAutoFit/>
+          </a:bodyPr>
+          <a:lstStyle/>
+          <a:p>
+            <a:pPr algn="ctr"/>
+            <a:r>
+              <a:rPr sz="6000" b="1" i="0">
+                <a:solidFill>
+                  <a:srgbClr val="00E5FF"/>
+                </a:solidFill>
+                <a:latin typeface="Calibri"/>
+              </a:rPr>
+              <a:t>“</a:t>
+            </a:r>
+          </a:p>
+        </p:txBody>
+      </p:sp>
+      <p:sp>
+        <p:nvSpPr>
           <p:cNvPr id="25" name="TextBox 24"/>
           <p:cNvSpPr txBox="1"/>
           <p:nvPr/>
         </p:nvSpPr>
         <p:spPr>
           <a:xfrm>
-            <a:off x="6080760" y="1371600"/>
-            <a:ext cx="548640" cy="640080"/>
-          </a:xfrm>
-          <a:prstGeom prst="rect">
-            <a:avLst/>
-          </a:prstGeom>
-          <a:noFill/>
-        </p:spPr>
-        <p:txBody>
-          <a:bodyPr wrap="square">
-            <a:spAutoFit/>
-          </a:bodyPr>
-          <a:lstStyle/>
-          <a:p>
-            <a:pPr algn="l"/>
-            <a:r>
-              <a:rPr sz="6000" b="1" i="0">
-                <a:solidFill>
-                  <a:srgbClr val="00E5FF"/>
-                </a:solidFill>
-                <a:latin typeface="Calibri"/>
-              </a:rPr>
-              <a:t>“</a:t>
-            </a:r>
-          </a:p>
-        </p:txBody>
-      </p:sp>
-      <p:sp>
-        <p:nvSpPr>
-          <p:cNvPr id="26" name="TextBox 25"/>
-          <p:cNvSpPr txBox="1"/>
-          <p:nvPr/>
-        </p:nvSpPr>
-        <p:spPr>
-          <a:xfrm>
-            <a:off x="6126480" y="1828800"/>
+            <a:off x="6126480" y="1709928"/>
             <a:ext cx="5577840" cy="1463040"/>
           </a:xfrm>
           <a:prstGeom prst="rect">
@@ -12752,13 +12705,13 @@
       </p:sp>
       <p:sp>
         <p:nvSpPr>
-          <p:cNvPr id="27" name="TextBox 26"/>
-          <p:cNvSpPr txBox="1"/>
-          <p:nvPr/>
-        </p:nvSpPr>
-        <p:spPr>
-          <a:xfrm>
-            <a:off x="6126480" y="3337560"/>
+          <p:cNvPr id="26" name="TextBox 25"/>
+          <p:cNvSpPr txBox="1"/>
+          <p:nvPr/>
+        </p:nvSpPr>
+        <p:spPr>
+          <a:xfrm>
+            <a:off x="6126480" y="3218688"/>
             <a:ext cx="5577840" cy="320040"/>
           </a:xfrm>
           <a:prstGeom prst="rect">
@@ -12787,14 +12740,14 @@
       </p:sp>
       <p:sp>
         <p:nvSpPr>
-          <p:cNvPr id="28" name="Rectangle 27"/>
+          <p:cNvPr id="27" name="Rectangle 26"/>
           <p:cNvSpPr/>
           <p:nvPr/>
         </p:nvSpPr>
         <p:spPr>
           <a:xfrm>
-            <a:off x="5943600" y="3794760"/>
-            <a:ext cx="5943600" cy="365760"/>
+            <a:off x="5943600" y="3675887"/>
+            <a:ext cx="5943600" cy="347472"/>
           </a:xfrm>
           <a:prstGeom prst="rect">
             <a:avLst/>
@@ -12831,14 +12784,14 @@
       </p:sp>
       <p:sp>
         <p:nvSpPr>
-          <p:cNvPr id="29" name="TextBox 28"/>
-          <p:cNvSpPr txBox="1"/>
-          <p:nvPr/>
-        </p:nvSpPr>
-        <p:spPr>
-          <a:xfrm>
-            <a:off x="6126480" y="3822191"/>
-            <a:ext cx="5669280" cy="320040"/>
+          <p:cNvPr id="28" name="TextBox 27"/>
+          <p:cNvSpPr txBox="1"/>
+          <p:nvPr/>
+        </p:nvSpPr>
+        <p:spPr>
+          <a:xfrm>
+            <a:off x="6126480" y="3703320"/>
+            <a:ext cx="5669280" cy="301752"/>
           </a:xfrm>
           <a:prstGeom prst="rect">
             <a:avLst/>
@@ -12866,14 +12819,14 @@
       </p:sp>
       <p:sp>
         <p:nvSpPr>
-          <p:cNvPr id="30" name="Rectangle 29"/>
+          <p:cNvPr id="29" name="Rectangle 28"/>
           <p:cNvSpPr/>
           <p:nvPr/>
         </p:nvSpPr>
         <p:spPr>
           <a:xfrm>
-            <a:off x="5943600" y="4160520"/>
-            <a:ext cx="5943600" cy="1325880"/>
+            <a:off x="5943600" y="4041648"/>
+            <a:ext cx="5943600" cy="1298448"/>
           </a:xfrm>
           <a:prstGeom prst="rect">
             <a:avLst/>
@@ -12912,80 +12865,49 @@
       </p:sp>
       <p:sp>
         <p:nvSpPr>
-          <p:cNvPr id="31" name="TextBox 30"/>
-          <p:cNvSpPr txBox="1"/>
-          <p:nvPr/>
-        </p:nvSpPr>
-        <p:spPr>
-          <a:xfrm>
-            <a:off x="6126480" y="4224528"/>
-            <a:ext cx="5623560" cy="1188720"/>
-          </a:xfrm>
-          <a:prstGeom prst="rect">
-            <a:avLst/>
-          </a:prstGeom>
-          <a:noFill/>
-        </p:spPr>
-        <p:txBody>
-          <a:bodyPr wrap="square">
-            <a:spAutoFit/>
-          </a:bodyPr>
-          <a:lstStyle/>
-          <a:p>
-            <a:r>
-              <a:rPr sz="1300">
+          <p:cNvPr id="30" name="TextBox 29"/>
+          <p:cNvSpPr txBox="1"/>
+          <p:nvPr/>
+        </p:nvSpPr>
+        <p:spPr>
+          <a:xfrm>
+            <a:off x="6126480" y="4114800"/>
+            <a:ext cx="5623560" cy="1152144"/>
+          </a:xfrm>
+          <a:prstGeom prst="rect">
+            <a:avLst/>
+          </a:prstGeom>
+          <a:noFill/>
+        </p:spPr>
+        <p:txBody>
+          <a:bodyPr wrap="square">
+            <a:spAutoFit/>
+          </a:bodyPr>
+          <a:lstStyle/>
+          <a:p>
+            <a:pPr algn="l"/>
+            <a:r>
+              <a:rPr sz="1250" b="0" i="0">
                 <a:solidFill>
                   <a:srgbClr val="A0AAB8"/>
                 </a:solidFill>
                 <a:latin typeface="Calibri"/>
               </a:rPr>
-              <a:t>Existing systems have no structured model of the target environment</a:t>
-            </a:r>
-          </a:p>
-          <a:p>
-            <a:r>
-              <a:rPr sz="1300">
-                <a:solidFill>
-                  <a:srgbClr val="A0AAB8"/>
-                </a:solidFill>
-                <a:latin typeface="Calibri"/>
-              </a:rPr>
-              <a:t>and no structured model of what attack paths are possible.</a:t>
-            </a:r>
-          </a:p>
-          <a:p>
-            <a:r>
-              <a:rPr sz="1300">
-                <a:solidFill>
-                  <a:srgbClr val="FFFFFF"/>
-                </a:solidFill>
-                <a:latin typeface="Calibri"/>
-              </a:rPr>
-              <a:t/>
-            </a:r>
-          </a:p>
-          <a:p>
-            <a:r>
-              <a:rPr sz="1300">
-                <a:solidFill>
-                  <a:srgbClr val="A0AAB8"/>
-                </a:solidFill>
-                <a:latin typeface="Calibri"/>
-              </a:rPr>
-              <a:t>They know what they did — not what the target is, or what can be done to it.</a:t>
-            </a:r>
-          </a:p>
-        </p:txBody>
-      </p:sp>
-      <p:sp>
-        <p:nvSpPr>
-          <p:cNvPr id="32" name="Rectangle 31"/>
+              <a:t>Existing systems have no structured model of the target environment and no structured model of what attack paths are possible.
+They know what they did — not what the target is, or what can be done to it.</a:t>
+            </a:r>
+          </a:p>
+        </p:txBody>
+      </p:sp>
+      <p:sp>
+        <p:nvSpPr>
+          <p:cNvPr id="31" name="Rectangle 30"/>
           <p:cNvSpPr/>
           <p:nvPr/>
         </p:nvSpPr>
         <p:spPr>
           <a:xfrm>
-            <a:off x="274320" y="5687568"/>
+            <a:off x="274320" y="5559552"/>
             <a:ext cx="11643055" cy="777240"/>
           </a:xfrm>
           <a:prstGeom prst="rect">
@@ -13025,49 +12947,49 @@
       </p:sp>
       <p:sp>
         <p:nvSpPr>
+          <p:cNvPr id="32" name="TextBox 31"/>
+          <p:cNvSpPr txBox="1"/>
+          <p:nvPr/>
+        </p:nvSpPr>
+        <p:spPr>
+          <a:xfrm>
+            <a:off x="457200" y="5650992"/>
+            <a:ext cx="11277295" cy="566928"/>
+          </a:xfrm>
+          <a:prstGeom prst="rect">
+            <a:avLst/>
+          </a:prstGeom>
+          <a:noFill/>
+        </p:spPr>
+        <p:txBody>
+          <a:bodyPr wrap="square">
+            <a:spAutoFit/>
+          </a:bodyPr>
+          <a:lstStyle/>
+          <a:p>
+            <a:pPr algn="l"/>
+            <a:r>
+              <a:rPr sz="1400" b="1" i="0">
+                <a:solidFill>
+                  <a:srgbClr val="00E5FF"/>
+                </a:solidFill>
+                <a:latin typeface="Calibri"/>
+              </a:rPr>
+              <a:t>CMatrix Solution →  Dual-graph world model: ASG captures discovered reality  ·  APG captures inferred attack opportunity</a:t>
+            </a:r>
+          </a:p>
+        </p:txBody>
+      </p:sp>
+      <p:sp>
+        <p:nvSpPr>
           <p:cNvPr id="33" name="TextBox 32"/>
           <p:cNvSpPr txBox="1"/>
           <p:nvPr/>
         </p:nvSpPr>
         <p:spPr>
           <a:xfrm>
-            <a:off x="457200" y="5760720"/>
-            <a:ext cx="11277295" cy="594360"/>
-          </a:xfrm>
-          <a:prstGeom prst="rect">
-            <a:avLst/>
-          </a:prstGeom>
-          <a:noFill/>
-        </p:spPr>
-        <p:txBody>
-          <a:bodyPr wrap="square">
-            <a:spAutoFit/>
-          </a:bodyPr>
-          <a:lstStyle/>
-          <a:p>
-            <a:pPr algn="l"/>
-            <a:r>
-              <a:rPr sz="1400" b="1" i="0">
-                <a:solidFill>
-                  <a:srgbClr val="00E5FF"/>
-                </a:solidFill>
-                <a:latin typeface="Calibri"/>
-              </a:rPr>
-              <a:t>CMatrix Solution →  A dual-graph world model: ASG captures discovered reality · APG captures inferred attack opportunity</a:t>
-            </a:r>
-          </a:p>
-        </p:txBody>
-      </p:sp>
-      <p:sp>
-        <p:nvSpPr>
-          <p:cNvPr id="34" name="TextBox 33"/>
-          <p:cNvSpPr txBox="1"/>
-          <p:nvPr/>
-        </p:nvSpPr>
-        <p:spPr>
-          <a:xfrm>
-            <a:off x="11368735" y="6355080"/>
-            <a:ext cx="640080" cy="411480"/>
+            <a:off x="11780215" y="6355080"/>
+            <a:ext cx="384048" cy="411480"/>
           </a:xfrm>
           <a:prstGeom prst="rect">
             <a:avLst/>
@@ -13259,8 +13181,8 @@
         </p:nvSpPr>
         <p:spPr>
           <a:xfrm>
-            <a:off x="274320" y="73152"/>
-            <a:ext cx="7315200" cy="320040"/>
+            <a:off x="274320" y="64008"/>
+            <a:ext cx="7315200" cy="237744"/>
           </a:xfrm>
           <a:prstGeom prst="rect">
             <a:avLst/>
@@ -13275,7 +13197,7 @@
           <a:p>
             <a:pPr algn="l"/>
             <a:r>
-              <a:rPr sz="1100" b="1" i="0">
+              <a:rPr sz="1000" b="1" i="0">
                 <a:solidFill>
                   <a:srgbClr val="FFD700"/>
                 </a:solidFill>
@@ -13294,8 +13216,8 @@
         </p:nvSpPr>
         <p:spPr>
           <a:xfrm>
-            <a:off x="274320" y="393192"/>
-            <a:ext cx="11430000" cy="685800"/>
+            <a:off x="274320" y="292608"/>
+            <a:ext cx="11430000" cy="475488"/>
           </a:xfrm>
           <a:prstGeom prst="rect">
             <a:avLst/>
@@ -13310,7 +13232,7 @@
           <a:p>
             <a:pPr algn="l"/>
             <a:r>
-              <a:rPr sz="3400" b="1" i="0">
+              <a:rPr sz="3200" b="1" i="0">
                 <a:solidFill>
                   <a:srgbClr val="FFFFFF"/>
                 </a:solidFill>
@@ -13330,51 +13252,7 @@
         <p:spPr>
           <a:xfrm>
             <a:off x="274320" y="1097280"/>
-            <a:ext cx="6400800" cy="32004"/>
-          </a:xfrm>
-          <a:prstGeom prst="rect">
-            <a:avLst/>
-          </a:prstGeom>
-          <a:solidFill>
-            <a:srgbClr val="FFD700"/>
-          </a:solidFill>
-          <a:ln>
-            <a:noFill/>
-          </a:ln>
-          <a:effectLst/>
-        </p:spPr>
-        <p:style>
-          <a:lnRef idx="1">
-            <a:schemeClr val="accent1"/>
-          </a:lnRef>
-          <a:fillRef idx="3">
-            <a:schemeClr val="accent1"/>
-          </a:fillRef>
-          <a:effectRef idx="2">
-            <a:schemeClr val="accent1"/>
-          </a:effectRef>
-          <a:fontRef idx="minor">
-            <a:schemeClr val="lt1"/>
-          </a:fontRef>
-        </p:style>
-        <p:txBody>
-          <a:bodyPr rtlCol="0" anchor="ctr"/>
-          <a:lstStyle/>
-          <a:p>
-            <a:pPr algn="ctr"/>
-          </a:p>
-        </p:txBody>
-      </p:sp>
-      <p:sp>
-        <p:nvSpPr>
-          <p:cNvPr id="8" name="Rectangle 7"/>
-          <p:cNvSpPr/>
-          <p:nvPr/>
-        </p:nvSpPr>
-        <p:spPr>
-          <a:xfrm>
-            <a:off x="274320" y="1234440"/>
-            <a:ext cx="11643055" cy="530352"/>
+            <a:ext cx="11643055" cy="512064"/>
           </a:xfrm>
           <a:prstGeom prst="rect">
             <a:avLst/>
@@ -13413,14 +13291,14 @@
       </p:sp>
       <p:sp>
         <p:nvSpPr>
-          <p:cNvPr id="9" name="TextBox 8"/>
-          <p:cNvSpPr txBox="1"/>
-          <p:nvPr/>
-        </p:nvSpPr>
-        <p:spPr>
-          <a:xfrm>
-            <a:off x="502920" y="1298448"/>
-            <a:ext cx="11277295" cy="411480"/>
+          <p:cNvPr id="8" name="TextBox 7"/>
+          <p:cNvSpPr txBox="1"/>
+          <p:nvPr/>
+        </p:nvSpPr>
+        <p:spPr>
+          <a:xfrm>
+            <a:off x="502920" y="1170432"/>
+            <a:ext cx="11277295" cy="402336"/>
           </a:xfrm>
           <a:prstGeom prst="rect">
             <a:avLst/>
@@ -13448,13 +13326,13 @@
       </p:sp>
       <p:sp>
         <p:nvSpPr>
-          <p:cNvPr id="10" name="Rectangle 9"/>
+          <p:cNvPr id="9" name="Rectangle 8"/>
           <p:cNvSpPr/>
           <p:nvPr/>
         </p:nvSpPr>
         <p:spPr>
           <a:xfrm>
-            <a:off x="274320" y="1920240"/>
+            <a:off x="274320" y="1783080"/>
             <a:ext cx="3794760" cy="1600200"/>
           </a:xfrm>
           <a:prstGeom prst="rect">
@@ -13494,13 +13372,13 @@
       </p:sp>
       <p:sp>
         <p:nvSpPr>
-          <p:cNvPr id="11" name="Rectangle 10"/>
+          <p:cNvPr id="10" name="Rectangle 9"/>
           <p:cNvSpPr/>
           <p:nvPr/>
         </p:nvSpPr>
         <p:spPr>
           <a:xfrm>
-            <a:off x="274320" y="1920240"/>
+            <a:off x="274320" y="1783080"/>
             <a:ext cx="502920" cy="384048"/>
           </a:xfrm>
           <a:prstGeom prst="rect">
@@ -13538,35 +13416,70 @@
       </p:sp>
       <p:sp>
         <p:nvSpPr>
+          <p:cNvPr id="11" name="TextBox 10"/>
+          <p:cNvSpPr txBox="1"/>
+          <p:nvPr/>
+        </p:nvSpPr>
+        <p:spPr>
+          <a:xfrm>
+            <a:off x="292608" y="1810512"/>
+            <a:ext cx="475488" cy="329184"/>
+          </a:xfrm>
+          <a:prstGeom prst="rect">
+            <a:avLst/>
+          </a:prstGeom>
+          <a:noFill/>
+        </p:spPr>
+        <p:txBody>
+          <a:bodyPr wrap="square">
+            <a:spAutoFit/>
+          </a:bodyPr>
+          <a:lstStyle/>
+          <a:p>
+            <a:pPr algn="ctr"/>
+            <a:r>
+              <a:rPr sz="1100" b="1" i="0">
+                <a:solidFill>
+                  <a:srgbClr val="0A0D1A"/>
+                </a:solidFill>
+                <a:latin typeface="Calibri"/>
+              </a:rPr>
+              <a:t>C1</a:t>
+            </a:r>
+          </a:p>
+        </p:txBody>
+      </p:sp>
+      <p:sp>
+        <p:nvSpPr>
           <p:cNvPr id="12" name="TextBox 11"/>
           <p:cNvSpPr txBox="1"/>
           <p:nvPr/>
         </p:nvSpPr>
         <p:spPr>
           <a:xfrm>
-            <a:off x="292608" y="1947672"/>
-            <a:ext cx="475488" cy="329184"/>
-          </a:xfrm>
-          <a:prstGeom prst="rect">
-            <a:avLst/>
-          </a:prstGeom>
-          <a:noFill/>
-        </p:spPr>
-        <p:txBody>
-          <a:bodyPr wrap="square">
-            <a:spAutoFit/>
-          </a:bodyPr>
-          <a:lstStyle/>
-          <a:p>
-            <a:pPr algn="ctr"/>
-            <a:r>
-              <a:rPr sz="1100" b="1" i="0">
-                <a:solidFill>
-                  <a:srgbClr val="0A0D1A"/>
-                </a:solidFill>
-                <a:latin typeface="Calibri"/>
-              </a:rPr>
-              <a:t>C1</a:t>
+            <a:off x="841248" y="1847088"/>
+            <a:ext cx="3154680" cy="347472"/>
+          </a:xfrm>
+          <a:prstGeom prst="rect">
+            <a:avLst/>
+          </a:prstGeom>
+          <a:noFill/>
+        </p:spPr>
+        <p:txBody>
+          <a:bodyPr wrap="square">
+            <a:spAutoFit/>
+          </a:bodyPr>
+          <a:lstStyle/>
+          <a:p>
+            <a:pPr algn="l"/>
+            <a:r>
+              <a:rPr sz="1300" b="1" i="0">
+                <a:solidFill>
+                  <a:srgbClr val="FFFFFF"/>
+                </a:solidFill>
+                <a:latin typeface="Calibri"/>
+              </a:rPr>
+              <a:t>Dual-Graph World Model</a:t>
             </a:r>
           </a:p>
         </p:txBody>
@@ -13579,8 +13492,8 @@
         </p:nvSpPr>
         <p:spPr>
           <a:xfrm>
-            <a:off x="841248" y="1984248"/>
-            <a:ext cx="3154680" cy="347472"/>
+            <a:off x="384048" y="2258568"/>
+            <a:ext cx="3611880" cy="1051560"/>
           </a:xfrm>
           <a:prstGeom prst="rect">
             <a:avLst/>
@@ -13595,41 +13508,6 @@
           <a:p>
             <a:pPr algn="l"/>
             <a:r>
-              <a:rPr sz="1300" b="1" i="0">
-                <a:solidFill>
-                  <a:srgbClr val="FFFFFF"/>
-                </a:solidFill>
-                <a:latin typeface="Calibri"/>
-              </a:rPr>
-              <a:t>Dual-Graph World Model</a:t>
-            </a:r>
-          </a:p>
-        </p:txBody>
-      </p:sp>
-      <p:sp>
-        <p:nvSpPr>
-          <p:cNvPr id="14" name="TextBox 13"/>
-          <p:cNvSpPr txBox="1"/>
-          <p:nvPr/>
-        </p:nvSpPr>
-        <p:spPr>
-          <a:xfrm>
-            <a:off x="384048" y="2395728"/>
-            <a:ext cx="3611880" cy="1051560"/>
-          </a:xfrm>
-          <a:prstGeom prst="rect">
-            <a:avLst/>
-          </a:prstGeom>
-          <a:noFill/>
-        </p:spPr>
-        <p:txBody>
-          <a:bodyPr wrap="square">
-            <a:spAutoFit/>
-          </a:bodyPr>
-          <a:lstStyle/>
-          <a:p>
-            <a:pPr algn="l"/>
-            <a:r>
               <a:rPr sz="1100" b="0" i="0">
                 <a:solidFill>
                   <a:srgbClr val="A0AAB8"/>
@@ -13643,13 +13521,13 @@
       </p:sp>
       <p:sp>
         <p:nvSpPr>
-          <p:cNvPr id="15" name="Rectangle 14"/>
+          <p:cNvPr id="14" name="Rectangle 13"/>
           <p:cNvSpPr/>
           <p:nvPr/>
         </p:nvSpPr>
         <p:spPr>
           <a:xfrm>
-            <a:off x="4187952" y="1920240"/>
+            <a:off x="4187952" y="1783080"/>
             <a:ext cx="3794760" cy="1600200"/>
           </a:xfrm>
           <a:prstGeom prst="rect">
@@ -13689,13 +13567,13 @@
       </p:sp>
       <p:sp>
         <p:nvSpPr>
-          <p:cNvPr id="16" name="Rectangle 15"/>
+          <p:cNvPr id="15" name="Rectangle 14"/>
           <p:cNvSpPr/>
           <p:nvPr/>
         </p:nvSpPr>
         <p:spPr>
           <a:xfrm>
-            <a:off x="4187952" y="1920240"/>
+            <a:off x="4187952" y="1783080"/>
             <a:ext cx="502920" cy="384048"/>
           </a:xfrm>
           <a:prstGeom prst="rect">
@@ -13733,35 +13611,70 @@
       </p:sp>
       <p:sp>
         <p:nvSpPr>
+          <p:cNvPr id="16" name="TextBox 15"/>
+          <p:cNvSpPr txBox="1"/>
+          <p:nvPr/>
+        </p:nvSpPr>
+        <p:spPr>
+          <a:xfrm>
+            <a:off x="4206240" y="1810512"/>
+            <a:ext cx="475488" cy="329184"/>
+          </a:xfrm>
+          <a:prstGeom prst="rect">
+            <a:avLst/>
+          </a:prstGeom>
+          <a:noFill/>
+        </p:spPr>
+        <p:txBody>
+          <a:bodyPr wrap="square">
+            <a:spAutoFit/>
+          </a:bodyPr>
+          <a:lstStyle/>
+          <a:p>
+            <a:pPr algn="ctr"/>
+            <a:r>
+              <a:rPr sz="1100" b="1" i="0">
+                <a:solidFill>
+                  <a:srgbClr val="0A0D1A"/>
+                </a:solidFill>
+                <a:latin typeface="Calibri"/>
+              </a:rPr>
+              <a:t>C2</a:t>
+            </a:r>
+          </a:p>
+        </p:txBody>
+      </p:sp>
+      <p:sp>
+        <p:nvSpPr>
           <p:cNvPr id="17" name="TextBox 16"/>
           <p:cNvSpPr txBox="1"/>
           <p:nvPr/>
         </p:nvSpPr>
         <p:spPr>
           <a:xfrm>
-            <a:off x="4206240" y="1947672"/>
-            <a:ext cx="475488" cy="329184"/>
-          </a:xfrm>
-          <a:prstGeom prst="rect">
-            <a:avLst/>
-          </a:prstGeom>
-          <a:noFill/>
-        </p:spPr>
-        <p:txBody>
-          <a:bodyPr wrap="square">
-            <a:spAutoFit/>
-          </a:bodyPr>
-          <a:lstStyle/>
-          <a:p>
-            <a:pPr algn="ctr"/>
-            <a:r>
-              <a:rPr sz="1100" b="1" i="0">
-                <a:solidFill>
-                  <a:srgbClr val="0A0D1A"/>
-                </a:solidFill>
-                <a:latin typeface="Calibri"/>
-              </a:rPr>
-              <a:t>C2</a:t>
+            <a:off x="4754880" y="1847088"/>
+            <a:ext cx="3154680" cy="347472"/>
+          </a:xfrm>
+          <a:prstGeom prst="rect">
+            <a:avLst/>
+          </a:prstGeom>
+          <a:noFill/>
+        </p:spPr>
+        <p:txBody>
+          <a:bodyPr wrap="square">
+            <a:spAutoFit/>
+          </a:bodyPr>
+          <a:lstStyle/>
+          <a:p>
+            <a:pPr algn="l"/>
+            <a:r>
+              <a:rPr sz="1300" b="1" i="0">
+                <a:solidFill>
+                  <a:srgbClr val="FFFFFF"/>
+                </a:solidFill>
+                <a:latin typeface="Calibri"/>
+              </a:rPr>
+              <a:t>Graph-State-Driven Re-Planning</a:t>
             </a:r>
           </a:p>
         </p:txBody>
@@ -13774,8 +13687,8 @@
         </p:nvSpPr>
         <p:spPr>
           <a:xfrm>
-            <a:off x="4754880" y="1984248"/>
-            <a:ext cx="3154680" cy="347472"/>
+            <a:off x="4297680" y="2258568"/>
+            <a:ext cx="3611880" cy="1051560"/>
           </a:xfrm>
           <a:prstGeom prst="rect">
             <a:avLst/>
@@ -13790,41 +13703,6 @@
           <a:p>
             <a:pPr algn="l"/>
             <a:r>
-              <a:rPr sz="1300" b="1" i="0">
-                <a:solidFill>
-                  <a:srgbClr val="FFFFFF"/>
-                </a:solidFill>
-                <a:latin typeface="Calibri"/>
-              </a:rPr>
-              <a:t>Graph-State-Driven Re-Planning</a:t>
-            </a:r>
-          </a:p>
-        </p:txBody>
-      </p:sp>
-      <p:sp>
-        <p:nvSpPr>
-          <p:cNvPr id="19" name="TextBox 18"/>
-          <p:cNvSpPr txBox="1"/>
-          <p:nvPr/>
-        </p:nvSpPr>
-        <p:spPr>
-          <a:xfrm>
-            <a:off x="4297680" y="2395728"/>
-            <a:ext cx="3611880" cy="1051560"/>
-          </a:xfrm>
-          <a:prstGeom prst="rect">
-            <a:avLst/>
-          </a:prstGeom>
-          <a:noFill/>
-        </p:spPr>
-        <p:txBody>
-          <a:bodyPr wrap="square">
-            <a:spAutoFit/>
-          </a:bodyPr>
-          <a:lstStyle/>
-          <a:p>
-            <a:pPr algn="l"/>
-            <a:r>
               <a:rPr sz="1100" b="0" i="0">
                 <a:solidFill>
                   <a:srgbClr val="A0AAB8"/>
@@ -13838,13 +13716,13 @@
       </p:sp>
       <p:sp>
         <p:nvSpPr>
-          <p:cNvPr id="20" name="Rectangle 19"/>
+          <p:cNvPr id="19" name="Rectangle 18"/>
           <p:cNvSpPr/>
           <p:nvPr/>
         </p:nvSpPr>
         <p:spPr>
           <a:xfrm>
-            <a:off x="8101584" y="1920240"/>
+            <a:off x="8101584" y="1783080"/>
             <a:ext cx="3794760" cy="1600200"/>
           </a:xfrm>
           <a:prstGeom prst="rect">
@@ -13884,13 +13762,13 @@
       </p:sp>
       <p:sp>
         <p:nvSpPr>
-          <p:cNvPr id="21" name="Rectangle 20"/>
+          <p:cNvPr id="20" name="Rectangle 19"/>
           <p:cNvSpPr/>
           <p:nvPr/>
         </p:nvSpPr>
         <p:spPr>
           <a:xfrm>
-            <a:off x="8101584" y="1920240"/>
+            <a:off x="8101584" y="1783080"/>
             <a:ext cx="502920" cy="384048"/>
           </a:xfrm>
           <a:prstGeom prst="rect">
@@ -13928,35 +13806,70 @@
       </p:sp>
       <p:sp>
         <p:nvSpPr>
+          <p:cNvPr id="21" name="TextBox 20"/>
+          <p:cNvSpPr txBox="1"/>
+          <p:nvPr/>
+        </p:nvSpPr>
+        <p:spPr>
+          <a:xfrm>
+            <a:off x="8119872" y="1810512"/>
+            <a:ext cx="475488" cy="329184"/>
+          </a:xfrm>
+          <a:prstGeom prst="rect">
+            <a:avLst/>
+          </a:prstGeom>
+          <a:noFill/>
+        </p:spPr>
+        <p:txBody>
+          <a:bodyPr wrap="square">
+            <a:spAutoFit/>
+          </a:bodyPr>
+          <a:lstStyle/>
+          <a:p>
+            <a:pPr algn="ctr"/>
+            <a:r>
+              <a:rPr sz="1100" b="1" i="0">
+                <a:solidFill>
+                  <a:srgbClr val="0A0D1A"/>
+                </a:solidFill>
+                <a:latin typeface="Calibri"/>
+              </a:rPr>
+              <a:t>C3</a:t>
+            </a:r>
+          </a:p>
+        </p:txBody>
+      </p:sp>
+      <p:sp>
+        <p:nvSpPr>
           <p:cNvPr id="22" name="TextBox 21"/>
           <p:cNvSpPr txBox="1"/>
           <p:nvPr/>
         </p:nvSpPr>
         <p:spPr>
           <a:xfrm>
-            <a:off x="8119872" y="1947672"/>
-            <a:ext cx="475488" cy="329184"/>
-          </a:xfrm>
-          <a:prstGeom prst="rect">
-            <a:avLst/>
-          </a:prstGeom>
-          <a:noFill/>
-        </p:spPr>
-        <p:txBody>
-          <a:bodyPr wrap="square">
-            <a:spAutoFit/>
-          </a:bodyPr>
-          <a:lstStyle/>
-          <a:p>
-            <a:pPr algn="ctr"/>
-            <a:r>
-              <a:rPr sz="1100" b="1" i="0">
-                <a:solidFill>
-                  <a:srgbClr val="0A0D1A"/>
-                </a:solidFill>
-                <a:latin typeface="Calibri"/>
-              </a:rPr>
-              <a:t>C3</a:t>
+            <a:off x="8668512" y="1847088"/>
+            <a:ext cx="3154680" cy="347472"/>
+          </a:xfrm>
+          <a:prstGeom prst="rect">
+            <a:avLst/>
+          </a:prstGeom>
+          <a:noFill/>
+        </p:spPr>
+        <p:txBody>
+          <a:bodyPr wrap="square">
+            <a:spAutoFit/>
+          </a:bodyPr>
+          <a:lstStyle/>
+          <a:p>
+            <a:pPr algn="l"/>
+            <a:r>
+              <a:rPr sz="1300" b="1" i="0">
+                <a:solidFill>
+                  <a:srgbClr val="FFFFFF"/>
+                </a:solidFill>
+                <a:latin typeface="Calibri"/>
+              </a:rPr>
+              <a:t>APG Attack Chain Lifecycle</a:t>
             </a:r>
           </a:p>
         </p:txBody>
@@ -13969,8 +13882,8 @@
         </p:nvSpPr>
         <p:spPr>
           <a:xfrm>
-            <a:off x="8668512" y="1984248"/>
-            <a:ext cx="3154680" cy="347472"/>
+            <a:off x="8211312" y="2258568"/>
+            <a:ext cx="3611880" cy="1051560"/>
           </a:xfrm>
           <a:prstGeom prst="rect">
             <a:avLst/>
@@ -13985,41 +13898,6 @@
           <a:p>
             <a:pPr algn="l"/>
             <a:r>
-              <a:rPr sz="1300" b="1" i="0">
-                <a:solidFill>
-                  <a:srgbClr val="FFFFFF"/>
-                </a:solidFill>
-                <a:latin typeface="Calibri"/>
-              </a:rPr>
-              <a:t>APG Attack Chain Lifecycle</a:t>
-            </a:r>
-          </a:p>
-        </p:txBody>
-      </p:sp>
-      <p:sp>
-        <p:nvSpPr>
-          <p:cNvPr id="24" name="TextBox 23"/>
-          <p:cNvSpPr txBox="1"/>
-          <p:nvPr/>
-        </p:nvSpPr>
-        <p:spPr>
-          <a:xfrm>
-            <a:off x="8211312" y="2395728"/>
-            <a:ext cx="3611880" cy="1051560"/>
-          </a:xfrm>
-          <a:prstGeom prst="rect">
-            <a:avLst/>
-          </a:prstGeom>
-          <a:noFill/>
-        </p:spPr>
-        <p:txBody>
-          <a:bodyPr wrap="square">
-            <a:spAutoFit/>
-          </a:bodyPr>
-          <a:lstStyle/>
-          <a:p>
-            <a:pPr algn="l"/>
-            <a:r>
               <a:rPr sz="1100" b="0" i="0">
                 <a:solidFill>
                   <a:srgbClr val="A0AAB8"/>
@@ -14033,13 +13911,13 @@
       </p:sp>
       <p:sp>
         <p:nvSpPr>
-          <p:cNvPr id="25" name="Rectangle 24"/>
+          <p:cNvPr id="24" name="Rectangle 23"/>
           <p:cNvSpPr/>
           <p:nvPr/>
         </p:nvSpPr>
         <p:spPr>
           <a:xfrm>
-            <a:off x="274320" y="3630168"/>
+            <a:off x="274320" y="3493008"/>
             <a:ext cx="3794760" cy="1600200"/>
           </a:xfrm>
           <a:prstGeom prst="rect">
@@ -14079,13 +13957,13 @@
       </p:sp>
       <p:sp>
         <p:nvSpPr>
-          <p:cNvPr id="26" name="Rectangle 25"/>
+          <p:cNvPr id="25" name="Rectangle 24"/>
           <p:cNvSpPr/>
           <p:nvPr/>
         </p:nvSpPr>
         <p:spPr>
           <a:xfrm>
-            <a:off x="274320" y="3630168"/>
+            <a:off x="274320" y="3493008"/>
             <a:ext cx="502920" cy="384048"/>
           </a:xfrm>
           <a:prstGeom prst="rect">
@@ -14123,35 +14001,70 @@
       </p:sp>
       <p:sp>
         <p:nvSpPr>
+          <p:cNvPr id="26" name="TextBox 25"/>
+          <p:cNvSpPr txBox="1"/>
+          <p:nvPr/>
+        </p:nvSpPr>
+        <p:spPr>
+          <a:xfrm>
+            <a:off x="292608" y="3520440"/>
+            <a:ext cx="475488" cy="329184"/>
+          </a:xfrm>
+          <a:prstGeom prst="rect">
+            <a:avLst/>
+          </a:prstGeom>
+          <a:noFill/>
+        </p:spPr>
+        <p:txBody>
+          <a:bodyPr wrap="square">
+            <a:spAutoFit/>
+          </a:bodyPr>
+          <a:lstStyle/>
+          <a:p>
+            <a:pPr algn="ctr"/>
+            <a:r>
+              <a:rPr sz="1100" b="1" i="0">
+                <a:solidFill>
+                  <a:srgbClr val="0A0D1A"/>
+                </a:solidFill>
+                <a:latin typeface="Calibri"/>
+              </a:rPr>
+              <a:t>C5</a:t>
+            </a:r>
+          </a:p>
+        </p:txBody>
+      </p:sp>
+      <p:sp>
+        <p:nvSpPr>
           <p:cNvPr id="27" name="TextBox 26"/>
           <p:cNvSpPr txBox="1"/>
           <p:nvPr/>
         </p:nvSpPr>
         <p:spPr>
           <a:xfrm>
-            <a:off x="292608" y="3657600"/>
-            <a:ext cx="475488" cy="329184"/>
-          </a:xfrm>
-          <a:prstGeom prst="rect">
-            <a:avLst/>
-          </a:prstGeom>
-          <a:noFill/>
-        </p:spPr>
-        <p:txBody>
-          <a:bodyPr wrap="square">
-            <a:spAutoFit/>
-          </a:bodyPr>
-          <a:lstStyle/>
-          <a:p>
-            <a:pPr algn="ctr"/>
-            <a:r>
-              <a:rPr sz="1100" b="1" i="0">
-                <a:solidFill>
-                  <a:srgbClr val="0A0D1A"/>
-                </a:solidFill>
-                <a:latin typeface="Calibri"/>
-              </a:rPr>
-              <a:t>C5</a:t>
+            <a:off x="841248" y="3557016"/>
+            <a:ext cx="3154680" cy="347472"/>
+          </a:xfrm>
+          <a:prstGeom prst="rect">
+            <a:avLst/>
+          </a:prstGeom>
+          <a:noFill/>
+        </p:spPr>
+        <p:txBody>
+          <a:bodyPr wrap="square">
+            <a:spAutoFit/>
+          </a:bodyPr>
+          <a:lstStyle/>
+          <a:p>
+            <a:pPr algn="l"/>
+            <a:r>
+              <a:rPr sz="1300" b="1" i="0">
+                <a:solidFill>
+                  <a:srgbClr val="FFFFFF"/>
+                </a:solidFill>
+                <a:latin typeface="Calibri"/>
+              </a:rPr>
+              <a:t>Tool Risk Gate + Commander Mailbox</a:t>
             </a:r>
           </a:p>
         </p:txBody>
@@ -14164,8 +14077,8 @@
         </p:nvSpPr>
         <p:spPr>
           <a:xfrm>
-            <a:off x="841248" y="3694176"/>
-            <a:ext cx="3154680" cy="347472"/>
+            <a:off x="384048" y="3968496"/>
+            <a:ext cx="3611880" cy="1051560"/>
           </a:xfrm>
           <a:prstGeom prst="rect">
             <a:avLst/>
@@ -14180,41 +14093,6 @@
           <a:p>
             <a:pPr algn="l"/>
             <a:r>
-              <a:rPr sz="1300" b="1" i="0">
-                <a:solidFill>
-                  <a:srgbClr val="FFFFFF"/>
-                </a:solidFill>
-                <a:latin typeface="Calibri"/>
-              </a:rPr>
-              <a:t>Tool Risk Gate + Commander Mailbox</a:t>
-            </a:r>
-          </a:p>
-        </p:txBody>
-      </p:sp>
-      <p:sp>
-        <p:nvSpPr>
-          <p:cNvPr id="29" name="TextBox 28"/>
-          <p:cNvSpPr txBox="1"/>
-          <p:nvPr/>
-        </p:nvSpPr>
-        <p:spPr>
-          <a:xfrm>
-            <a:off x="384048" y="4105656"/>
-            <a:ext cx="3611880" cy="1051560"/>
-          </a:xfrm>
-          <a:prstGeom prst="rect">
-            <a:avLst/>
-          </a:prstGeom>
-          <a:noFill/>
-        </p:spPr>
-        <p:txBody>
-          <a:bodyPr wrap="square">
-            <a:spAutoFit/>
-          </a:bodyPr>
-          <a:lstStyle/>
-          <a:p>
-            <a:pPr algn="l"/>
-            <a:r>
               <a:rPr sz="1100" b="0" i="0">
                 <a:solidFill>
                   <a:srgbClr val="A0AAB8"/>
@@ -14228,13 +14106,13 @@
       </p:sp>
       <p:sp>
         <p:nvSpPr>
-          <p:cNvPr id="30" name="Rectangle 29"/>
+          <p:cNvPr id="29" name="Rectangle 28"/>
           <p:cNvSpPr/>
           <p:nvPr/>
         </p:nvSpPr>
         <p:spPr>
           <a:xfrm>
-            <a:off x="4187952" y="3630168"/>
+            <a:off x="4187952" y="3493008"/>
             <a:ext cx="3794760" cy="1600200"/>
           </a:xfrm>
           <a:prstGeom prst="rect">
@@ -14274,13 +14152,13 @@
       </p:sp>
       <p:sp>
         <p:nvSpPr>
-          <p:cNvPr id="31" name="Rectangle 30"/>
+          <p:cNvPr id="30" name="Rectangle 29"/>
           <p:cNvSpPr/>
           <p:nvPr/>
         </p:nvSpPr>
         <p:spPr>
           <a:xfrm>
-            <a:off x="4187952" y="3630168"/>
+            <a:off x="4187952" y="3493008"/>
             <a:ext cx="502920" cy="384048"/>
           </a:xfrm>
           <a:prstGeom prst="rect">
@@ -14318,35 +14196,70 @@
       </p:sp>
       <p:sp>
         <p:nvSpPr>
+          <p:cNvPr id="31" name="TextBox 30"/>
+          <p:cNvSpPr txBox="1"/>
+          <p:nvPr/>
+        </p:nvSpPr>
+        <p:spPr>
+          <a:xfrm>
+            <a:off x="4206240" y="3520440"/>
+            <a:ext cx="475488" cy="329184"/>
+          </a:xfrm>
+          <a:prstGeom prst="rect">
+            <a:avLst/>
+          </a:prstGeom>
+          <a:noFill/>
+        </p:spPr>
+        <p:txBody>
+          <a:bodyPr wrap="square">
+            <a:spAutoFit/>
+          </a:bodyPr>
+          <a:lstStyle/>
+          <a:p>
+            <a:pPr algn="ctr"/>
+            <a:r>
+              <a:rPr sz="1100" b="1" i="0">
+                <a:solidFill>
+                  <a:srgbClr val="0A0D1A"/>
+                </a:solidFill>
+                <a:latin typeface="Calibri"/>
+              </a:rPr>
+              <a:t>C10</a:t>
+            </a:r>
+          </a:p>
+        </p:txBody>
+      </p:sp>
+      <p:sp>
+        <p:nvSpPr>
           <p:cNvPr id="32" name="TextBox 31"/>
           <p:cNvSpPr txBox="1"/>
           <p:nvPr/>
         </p:nvSpPr>
         <p:spPr>
           <a:xfrm>
-            <a:off x="4206240" y="3657600"/>
-            <a:ext cx="475488" cy="329184"/>
-          </a:xfrm>
-          <a:prstGeom prst="rect">
-            <a:avLst/>
-          </a:prstGeom>
-          <a:noFill/>
-        </p:spPr>
-        <p:txBody>
-          <a:bodyPr wrap="square">
-            <a:spAutoFit/>
-          </a:bodyPr>
-          <a:lstStyle/>
-          <a:p>
-            <a:pPr algn="ctr"/>
-            <a:r>
-              <a:rPr sz="1100" b="1" i="0">
-                <a:solidFill>
-                  <a:srgbClr val="0A0D1A"/>
-                </a:solidFill>
-                <a:latin typeface="Calibri"/>
-              </a:rPr>
-              <a:t>C10</a:t>
+            <a:off x="4754880" y="3557016"/>
+            <a:ext cx="3154680" cy="347472"/>
+          </a:xfrm>
+          <a:prstGeom prst="rect">
+            <a:avLst/>
+          </a:prstGeom>
+          <a:noFill/>
+        </p:spPr>
+        <p:txBody>
+          <a:bodyPr wrap="square">
+            <a:spAutoFit/>
+          </a:bodyPr>
+          <a:lstStyle/>
+          <a:p>
+            <a:pPr algn="l"/>
+            <a:r>
+              <a:rPr sz="1300" b="1" i="0">
+                <a:solidFill>
+                  <a:srgbClr val="FFFFFF"/>
+                </a:solidFill>
+                <a:latin typeface="Calibri"/>
+              </a:rPr>
+              <a:t>Cross-Mission Experience Store</a:t>
             </a:r>
           </a:p>
         </p:txBody>
@@ -14359,8 +14272,8 @@
         </p:nvSpPr>
         <p:spPr>
           <a:xfrm>
-            <a:off x="4754880" y="3694176"/>
-            <a:ext cx="3154680" cy="347472"/>
+            <a:off x="4297680" y="3968496"/>
+            <a:ext cx="3611880" cy="1051560"/>
           </a:xfrm>
           <a:prstGeom prst="rect">
             <a:avLst/>
@@ -14375,41 +14288,6 @@
           <a:p>
             <a:pPr algn="l"/>
             <a:r>
-              <a:rPr sz="1300" b="1" i="0">
-                <a:solidFill>
-                  <a:srgbClr val="FFFFFF"/>
-                </a:solidFill>
-                <a:latin typeface="Calibri"/>
-              </a:rPr>
-              <a:t>Cross-Mission Experience Store</a:t>
-            </a:r>
-          </a:p>
-        </p:txBody>
-      </p:sp>
-      <p:sp>
-        <p:nvSpPr>
-          <p:cNvPr id="34" name="TextBox 33"/>
-          <p:cNvSpPr txBox="1"/>
-          <p:nvPr/>
-        </p:nvSpPr>
-        <p:spPr>
-          <a:xfrm>
-            <a:off x="4297680" y="4105656"/>
-            <a:ext cx="3611880" cy="1051560"/>
-          </a:xfrm>
-          <a:prstGeom prst="rect">
-            <a:avLst/>
-          </a:prstGeom>
-          <a:noFill/>
-        </p:spPr>
-        <p:txBody>
-          <a:bodyPr wrap="square">
-            <a:spAutoFit/>
-          </a:bodyPr>
-          <a:lstStyle/>
-          <a:p>
-            <a:pPr algn="l"/>
-            <a:r>
               <a:rPr sz="1100" b="0" i="0">
                 <a:solidFill>
                   <a:srgbClr val="A0AAB8"/>
@@ -14423,13 +14301,13 @@
       </p:sp>
       <p:sp>
         <p:nvSpPr>
-          <p:cNvPr id="35" name="Rectangle 34"/>
+          <p:cNvPr id="34" name="Rectangle 33"/>
           <p:cNvSpPr/>
           <p:nvPr/>
         </p:nvSpPr>
         <p:spPr>
           <a:xfrm>
-            <a:off x="8101584" y="3630168"/>
+            <a:off x="8101584" y="3493008"/>
             <a:ext cx="3794760" cy="1600200"/>
           </a:xfrm>
           <a:prstGeom prst="rect">
@@ -14469,13 +14347,13 @@
       </p:sp>
       <p:sp>
         <p:nvSpPr>
-          <p:cNvPr id="36" name="Rectangle 35"/>
+          <p:cNvPr id="35" name="Rectangle 34"/>
           <p:cNvSpPr/>
           <p:nvPr/>
         </p:nvSpPr>
         <p:spPr>
           <a:xfrm>
-            <a:off x="8101584" y="3630168"/>
+            <a:off x="8101584" y="3493008"/>
             <a:ext cx="502920" cy="384048"/>
           </a:xfrm>
           <a:prstGeom prst="rect">
@@ -14513,35 +14391,70 @@
       </p:sp>
       <p:sp>
         <p:nvSpPr>
+          <p:cNvPr id="36" name="TextBox 35"/>
+          <p:cNvSpPr txBox="1"/>
+          <p:nvPr/>
+        </p:nvSpPr>
+        <p:spPr>
+          <a:xfrm>
+            <a:off x="8119872" y="3520440"/>
+            <a:ext cx="475488" cy="329184"/>
+          </a:xfrm>
+          <a:prstGeom prst="rect">
+            <a:avLst/>
+          </a:prstGeom>
+          <a:noFill/>
+        </p:spPr>
+        <p:txBody>
+          <a:bodyPr wrap="square">
+            <a:spAutoFit/>
+          </a:bodyPr>
+          <a:lstStyle/>
+          <a:p>
+            <a:pPr algn="ctr"/>
+            <a:r>
+              <a:rPr sz="1100" b="1" i="0">
+                <a:solidFill>
+                  <a:srgbClr val="0A0D1A"/>
+                </a:solidFill>
+                <a:latin typeface="Calibri"/>
+              </a:rPr>
+              <a:t>C11</a:t>
+            </a:r>
+          </a:p>
+        </p:txBody>
+      </p:sp>
+      <p:sp>
+        <p:nvSpPr>
           <p:cNvPr id="37" name="TextBox 36"/>
           <p:cNvSpPr txBox="1"/>
           <p:nvPr/>
         </p:nvSpPr>
         <p:spPr>
           <a:xfrm>
-            <a:off x="8119872" y="3657600"/>
-            <a:ext cx="475488" cy="329184"/>
-          </a:xfrm>
-          <a:prstGeom prst="rect">
-            <a:avLst/>
-          </a:prstGeom>
-          <a:noFill/>
-        </p:spPr>
-        <p:txBody>
-          <a:bodyPr wrap="square">
-            <a:spAutoFit/>
-          </a:bodyPr>
-          <a:lstStyle/>
-          <a:p>
-            <a:pPr algn="ctr"/>
-            <a:r>
-              <a:rPr sz="1100" b="1" i="0">
-                <a:solidFill>
-                  <a:srgbClr val="0A0D1A"/>
-                </a:solidFill>
-                <a:latin typeface="Calibri"/>
-              </a:rPr>
-              <a:t>C11</a:t>
+            <a:off x="8668512" y="3557016"/>
+            <a:ext cx="3154680" cy="347472"/>
+          </a:xfrm>
+          <a:prstGeom prst="rect">
+            <a:avLst/>
+          </a:prstGeom>
+          <a:noFill/>
+        </p:spPr>
+        <p:txBody>
+          <a:bodyPr wrap="square">
+            <a:spAutoFit/>
+          </a:bodyPr>
+          <a:lstStyle/>
+          <a:p>
+            <a:pPr algn="l"/>
+            <a:r>
+              <a:rPr sz="1300" b="1" i="0">
+                <a:solidFill>
+                  <a:srgbClr val="FFFFFF"/>
+                </a:solidFill>
+                <a:latin typeface="Calibri"/>
+              </a:rPr>
+              <a:t>Attack Strategy Library</a:t>
             </a:r>
           </a:p>
         </p:txBody>
@@ -14554,8 +14467,8 @@
         </p:nvSpPr>
         <p:spPr>
           <a:xfrm>
-            <a:off x="8668512" y="3694176"/>
-            <a:ext cx="3154680" cy="347472"/>
+            <a:off x="8211312" y="3968496"/>
+            <a:ext cx="3611880" cy="1051560"/>
           </a:xfrm>
           <a:prstGeom prst="rect">
             <a:avLst/>
@@ -14570,41 +14483,6 @@
           <a:p>
             <a:pPr algn="l"/>
             <a:r>
-              <a:rPr sz="1300" b="1" i="0">
-                <a:solidFill>
-                  <a:srgbClr val="FFFFFF"/>
-                </a:solidFill>
-                <a:latin typeface="Calibri"/>
-              </a:rPr>
-              <a:t>Attack Strategy Library</a:t>
-            </a:r>
-          </a:p>
-        </p:txBody>
-      </p:sp>
-      <p:sp>
-        <p:nvSpPr>
-          <p:cNvPr id="39" name="TextBox 38"/>
-          <p:cNvSpPr txBox="1"/>
-          <p:nvPr/>
-        </p:nvSpPr>
-        <p:spPr>
-          <a:xfrm>
-            <a:off x="8211312" y="4105656"/>
-            <a:ext cx="3611880" cy="1051560"/>
-          </a:xfrm>
-          <a:prstGeom prst="rect">
-            <a:avLst/>
-          </a:prstGeom>
-          <a:noFill/>
-        </p:spPr>
-        <p:txBody>
-          <a:bodyPr wrap="square">
-            <a:spAutoFit/>
-          </a:bodyPr>
-          <a:lstStyle/>
-          <a:p>
-            <a:pPr algn="l"/>
-            <a:r>
               <a:rPr sz="1100" b="0" i="0">
                 <a:solidFill>
                   <a:srgbClr val="A0AAB8"/>
@@ -14618,13 +14496,13 @@
       </p:sp>
       <p:sp>
         <p:nvSpPr>
-          <p:cNvPr id="40" name="Rectangle 39"/>
+          <p:cNvPr id="39" name="Rectangle 38"/>
           <p:cNvSpPr/>
           <p:nvPr/>
         </p:nvSpPr>
         <p:spPr>
           <a:xfrm>
-            <a:off x="274320" y="5285232"/>
+            <a:off x="274320" y="5212080"/>
             <a:ext cx="11643055" cy="457200"/>
           </a:xfrm>
           <a:prstGeom prst="rect">
@@ -14664,49 +14542,49 @@
       </p:sp>
       <p:sp>
         <p:nvSpPr>
+          <p:cNvPr id="40" name="TextBox 39"/>
+          <p:cNvSpPr txBox="1"/>
+          <p:nvPr/>
+        </p:nvSpPr>
+        <p:spPr>
+          <a:xfrm>
+            <a:off x="502920" y="5276088"/>
+            <a:ext cx="11368735" cy="347472"/>
+          </a:xfrm>
+          <a:prstGeom prst="rect">
+            <a:avLst/>
+          </a:prstGeom>
+          <a:noFill/>
+        </p:spPr>
+        <p:txBody>
+          <a:bodyPr wrap="none">
+            <a:spAutoFit/>
+          </a:bodyPr>
+          <a:lstStyle/>
+          <a:p>
+            <a:pPr algn="l"/>
+            <a:r>
+              <a:rPr sz="1050" b="0" i="0">
+                <a:solidFill>
+                  <a:srgbClr val="A0AAB8"/>
+                </a:solidFill>
+                <a:latin typeface="Calibri"/>
+              </a:rPr>
+              <a:t>12 novel research contributions in total  ·  C4: ASG-aware parallel dispatch  ·  C6: Lossless context compaction  ·  C7: Methodology-as-config  ·  C8: Dual-graph termination  ·  C9: Live CVE grounding  ·  C12: Trajectory export dataset</a:t>
+            </a:r>
+          </a:p>
+        </p:txBody>
+      </p:sp>
+      <p:sp>
+        <p:nvSpPr>
           <p:cNvPr id="41" name="TextBox 40"/>
           <p:cNvSpPr txBox="1"/>
           <p:nvPr/>
         </p:nvSpPr>
         <p:spPr>
           <a:xfrm>
-            <a:off x="502920" y="5340096"/>
-            <a:ext cx="11368735" cy="365760"/>
-          </a:xfrm>
-          <a:prstGeom prst="rect">
-            <a:avLst/>
-          </a:prstGeom>
-          <a:noFill/>
-        </p:spPr>
-        <p:txBody>
-          <a:bodyPr wrap="none">
-            <a:spAutoFit/>
-          </a:bodyPr>
-          <a:lstStyle/>
-          <a:p>
-            <a:pPr algn="l"/>
-            <a:r>
-              <a:rPr sz="1050" b="0" i="0">
-                <a:solidFill>
-                  <a:srgbClr val="A0AAB8"/>
-                </a:solidFill>
-                <a:latin typeface="Calibri"/>
-              </a:rPr>
-              <a:t>12 novel research contributions in total  ·  C4: ASG-aware parallel dispatch  ·  C6: Lossless context compaction  ·  C7: Methodology-as-config  ·  C8: Dual-graph termination  ·  C9: Live CVE grounding  ·  C12: Trajectory export dataset</a:t>
-            </a:r>
-          </a:p>
-        </p:txBody>
-      </p:sp>
-      <p:sp>
-        <p:nvSpPr>
-          <p:cNvPr id="42" name="TextBox 41"/>
-          <p:cNvSpPr txBox="1"/>
-          <p:nvPr/>
-        </p:nvSpPr>
-        <p:spPr>
-          <a:xfrm>
-            <a:off x="11368735" y="6355080"/>
-            <a:ext cx="640080" cy="411480"/>
+            <a:off x="11780215" y="6355080"/>
+            <a:ext cx="384048" cy="411480"/>
           </a:xfrm>
           <a:prstGeom prst="rect">
             <a:avLst/>
@@ -15220,7 +15098,7 @@
             <a:r>
               <a:rPr sz="700" b="0" i="1">
                 <a:solidFill>
-                  <a:srgbClr val="404858"/>
+                  <a:srgbClr val="303848"/>
                 </a:solidFill>
                 <a:latin typeface="Calibri"/>
               </a:rPr>
@@ -17152,7 +17030,7 @@
             <a:avLst/>
           </a:prstGeom>
           <a:solidFill>
-            <a:srgbClr val="404858"/>
+            <a:srgbClr val="303848"/>
           </a:solidFill>
           <a:ln>
             <a:noFill/>
@@ -20126,7 +20004,7 @@
             <a:solidFill>
               <a:srgbClr val="39FF14"/>
             </a:solidFill>
-            <a:headEnd type="arrow" w="sm" len="med"/>
+            <a:headEnd type="arrow" w="med" len="med"/>
             <a:tailEnd type="none"/>
           </a:ln>
         </p:spPr>
@@ -20199,7 +20077,7 @@
             <a:solidFill>
               <a:srgbClr val="FFD700"/>
             </a:solidFill>
-            <a:headEnd type="arrow" w="sm" len="med"/>
+            <a:headEnd type="arrow" w="med" len="med"/>
             <a:tailEnd type="none"/>
           </a:ln>
         </p:spPr>
@@ -21316,7 +21194,7 @@
             <a:solidFill>
               <a:srgbClr val="39FF14"/>
             </a:solidFill>
-            <a:headEnd type="arrow" w="sm" len="med"/>
+            <a:headEnd type="arrow" w="med" len="med"/>
             <a:tailEnd type="none"/>
           </a:ln>
         </p:spPr>
@@ -21388,7 +21266,7 @@
             <a:solidFill>
               <a:srgbClr val="39FF14"/>
             </a:solidFill>
-            <a:headEnd type="arrow" w="sm" len="med"/>
+            <a:headEnd type="arrow" w="med" len="med"/>
             <a:tailEnd type="none"/>
           </a:ln>
         </p:spPr>
@@ -21460,7 +21338,7 @@
             <a:solidFill>
               <a:srgbClr val="39FF14"/>
             </a:solidFill>
-            <a:headEnd type="arrow" w="sm" len="med"/>
+            <a:headEnd type="arrow" w="med" len="med"/>
             <a:tailEnd type="none"/>
           </a:ln>
         </p:spPr>
@@ -21532,7 +21410,7 @@
             <a:solidFill>
               <a:srgbClr val="39FF14"/>
             </a:solidFill>
-            <a:headEnd type="arrow" w="sm" len="med"/>
+            <a:headEnd type="arrow" w="med" len="med"/>
             <a:tailEnd type="none"/>
           </a:ln>
         </p:spPr>
@@ -21604,7 +21482,7 @@
             <a:solidFill>
               <a:srgbClr val="39FF14"/>
             </a:solidFill>
-            <a:headEnd type="arrow" w="sm" len="med"/>
+            <a:headEnd type="arrow" w="med" len="med"/>
             <a:tailEnd type="none"/>
           </a:ln>
         </p:spPr>
@@ -21676,7 +21554,7 @@
             <a:solidFill>
               <a:srgbClr val="00E5FF"/>
             </a:solidFill>
-            <a:headEnd type="arrow" w="sm" len="med"/>
+            <a:headEnd type="arrow" w="med" len="med"/>
             <a:tailEnd type="none"/>
           </a:ln>
         </p:spPr>
@@ -21748,7 +21626,7 @@
             <a:solidFill>
               <a:srgbClr val="00E5FF"/>
             </a:solidFill>
-            <a:headEnd type="arrow" w="sm" len="med"/>
+            <a:headEnd type="arrow" w="med" len="med"/>
             <a:tailEnd type="none"/>
           </a:ln>
         </p:spPr>
@@ -21820,7 +21698,7 @@
             <a:solidFill>
               <a:srgbClr val="00E5FF"/>
             </a:solidFill>
-            <a:headEnd type="arrow" w="sm" len="med"/>
+            <a:headEnd type="arrow" w="med" len="med"/>
             <a:tailEnd type="none"/>
           </a:ln>
         </p:spPr>
@@ -22329,7 +22207,7 @@
             <a:solidFill>
               <a:srgbClr val="FFD700"/>
             </a:solidFill>
-            <a:headEnd type="arrow" w="sm" len="med"/>
+            <a:headEnd type="arrow" w="med" len="med"/>
             <a:tailEnd type="none"/>
           </a:ln>
         </p:spPr>
@@ -22633,7 +22511,7 @@
             <a:solidFill>
               <a:srgbClr val="FFD700"/>
             </a:solidFill>
-            <a:headEnd type="arrow" w="sm" len="med"/>
+            <a:headEnd type="arrow" w="med" len="med"/>
             <a:tailEnd type="none"/>
           </a:ln>
         </p:spPr>
@@ -22937,7 +22815,7 @@
             <a:solidFill>
               <a:srgbClr val="FF4545"/>
             </a:solidFill>
-            <a:headEnd type="arrow" w="sm" len="med"/>
+            <a:headEnd type="arrow" w="med" len="med"/>
             <a:tailEnd type="none"/>
           </a:ln>
         </p:spPr>
@@ -23465,8 +23343,8 @@
         </p:nvSpPr>
         <p:spPr>
           <a:xfrm>
-            <a:off x="11825935" y="6382512"/>
-            <a:ext cx="320040" cy="384048"/>
+            <a:off x="11780215" y="6355080"/>
+            <a:ext cx="384048" cy="411480"/>
           </a:xfrm>
           <a:prstGeom prst="rect">
             <a:avLst/>
@@ -27363,7 +27241,7 @@
           </a:bodyPr>
           <a:lstStyle/>
           <a:p>
-            <a:pPr algn="l"/>
+            <a:pPr algn="ctr"/>
             <a:r>
               <a:rPr sz="1100" b="1" i="0">
                 <a:solidFill>
@@ -27398,7 +27276,7 @@
           </a:bodyPr>
           <a:lstStyle/>
           <a:p>
-            <a:pPr algn="l"/>
+            <a:pPr algn="ctr"/>
             <a:r>
               <a:rPr sz="3000" b="1" i="0">
                 <a:solidFill>
@@ -27926,7 +27804,7 @@
           </a:bodyPr>
           <a:lstStyle/>
           <a:p>
-            <a:pPr algn="l"/>
+            <a:pPr algn="ctr"/>
             <a:r>
               <a:rPr sz="1300" b="1" i="0">
                 <a:solidFill>
@@ -27961,7 +27839,7 @@
           </a:bodyPr>
           <a:lstStyle/>
           <a:p>
-            <a:pPr algn="l"/>
+            <a:pPr algn="ctr"/>
             <a:r>
               <a:rPr sz="850" b="0" i="1">
                 <a:solidFill>
@@ -27996,7 +27874,7 @@
           </a:bodyPr>
           <a:lstStyle/>
           <a:p>
-            <a:pPr algn="l"/>
+            <a:pPr algn="ctr"/>
             <a:r>
               <a:rPr sz="900" b="0" i="0">
                 <a:solidFill>
@@ -28156,7 +28034,7 @@
           </a:bodyPr>
           <a:lstStyle/>
           <a:p>
-            <a:pPr algn="l"/>
+            <a:pPr algn="ctr"/>
             <a:r>
               <a:rPr sz="1300" b="1" i="0">
                 <a:solidFill>
@@ -28191,7 +28069,7 @@
           </a:bodyPr>
           <a:lstStyle/>
           <a:p>
-            <a:pPr algn="l"/>
+            <a:pPr algn="ctr"/>
             <a:r>
               <a:rPr sz="850" b="0" i="1">
                 <a:solidFill>
@@ -28226,7 +28104,7 @@
           </a:bodyPr>
           <a:lstStyle/>
           <a:p>
-            <a:pPr algn="l"/>
+            <a:pPr algn="ctr"/>
             <a:r>
               <a:rPr sz="900" b="0" i="0">
                 <a:solidFill>
@@ -28386,7 +28264,7 @@
           </a:bodyPr>
           <a:lstStyle/>
           <a:p>
-            <a:pPr algn="l"/>
+            <a:pPr algn="ctr"/>
             <a:r>
               <a:rPr sz="1300" b="1" i="0">
                 <a:solidFill>
@@ -28421,7 +28299,7 @@
           </a:bodyPr>
           <a:lstStyle/>
           <a:p>
-            <a:pPr algn="l"/>
+            <a:pPr algn="ctr"/>
             <a:r>
               <a:rPr sz="850" b="0" i="1">
                 <a:solidFill>
@@ -28456,7 +28334,7 @@
           </a:bodyPr>
           <a:lstStyle/>
           <a:p>
-            <a:pPr algn="l"/>
+            <a:pPr algn="ctr"/>
             <a:r>
               <a:rPr sz="900" b="0" i="0">
                 <a:solidFill>
@@ -28616,7 +28494,7 @@
           </a:bodyPr>
           <a:lstStyle/>
           <a:p>
-            <a:pPr algn="l"/>
+            <a:pPr algn="ctr"/>
             <a:r>
               <a:rPr sz="1300" b="1" i="0">
                 <a:solidFill>
@@ -28651,7 +28529,7 @@
           </a:bodyPr>
           <a:lstStyle/>
           <a:p>
-            <a:pPr algn="l"/>
+            <a:pPr algn="ctr"/>
             <a:r>
               <a:rPr sz="850" b="0" i="1">
                 <a:solidFill>
@@ -28686,7 +28564,7 @@
           </a:bodyPr>
           <a:lstStyle/>
           <a:p>
-            <a:pPr algn="l"/>
+            <a:pPr algn="ctr"/>
             <a:r>
               <a:rPr sz="900" b="0" i="0">
                 <a:solidFill>
@@ -28846,7 +28724,7 @@
           </a:bodyPr>
           <a:lstStyle/>
           <a:p>
-            <a:pPr algn="l"/>
+            <a:pPr algn="ctr"/>
             <a:r>
               <a:rPr sz="1300" b="1" i="0">
                 <a:solidFill>
@@ -28881,7 +28759,7 @@
           </a:bodyPr>
           <a:lstStyle/>
           <a:p>
-            <a:pPr algn="l"/>
+            <a:pPr algn="ctr"/>
             <a:r>
               <a:rPr sz="850" b="0" i="1">
                 <a:solidFill>
@@ -28916,7 +28794,7 @@
           </a:bodyPr>
           <a:lstStyle/>
           <a:p>
-            <a:pPr algn="l"/>
+            <a:pPr algn="ctr"/>
             <a:r>
               <a:rPr sz="900" b="0" i="0">
                 <a:solidFill>
@@ -29076,7 +28954,7 @@
           </a:bodyPr>
           <a:lstStyle/>
           <a:p>
-            <a:pPr algn="l"/>
+            <a:pPr algn="ctr"/>
             <a:r>
               <a:rPr sz="1300" b="1" i="0">
                 <a:solidFill>
@@ -29111,7 +28989,7 @@
           </a:bodyPr>
           <a:lstStyle/>
           <a:p>
-            <a:pPr algn="l"/>
+            <a:pPr algn="ctr"/>
             <a:r>
               <a:rPr sz="850" b="0" i="1">
                 <a:solidFill>
@@ -29146,7 +29024,7 @@
           </a:bodyPr>
           <a:lstStyle/>
           <a:p>
-            <a:pPr algn="l"/>
+            <a:pPr algn="ctr"/>
             <a:r>
               <a:rPr sz="900" b="0" i="0">
                 <a:solidFill>
@@ -29306,7 +29184,7 @@
           </a:bodyPr>
           <a:lstStyle/>
           <a:p>
-            <a:pPr algn="l"/>
+            <a:pPr algn="ctr"/>
             <a:r>
               <a:rPr sz="1300" b="1" i="0">
                 <a:solidFill>
@@ -29341,7 +29219,7 @@
           </a:bodyPr>
           <a:lstStyle/>
           <a:p>
-            <a:pPr algn="l"/>
+            <a:pPr algn="ctr"/>
             <a:r>
               <a:rPr sz="850" b="0" i="1">
                 <a:solidFill>
@@ -29376,7 +29254,7 @@
           </a:bodyPr>
           <a:lstStyle/>
           <a:p>
-            <a:pPr algn="l"/>
+            <a:pPr algn="ctr"/>
             <a:r>
               <a:rPr sz="900" b="0" i="0">
                 <a:solidFill>
@@ -29536,7 +29414,7 @@
           </a:bodyPr>
           <a:lstStyle/>
           <a:p>
-            <a:pPr algn="l"/>
+            <a:pPr algn="ctr"/>
             <a:r>
               <a:rPr sz="1300" b="1" i="0">
                 <a:solidFill>
@@ -29571,7 +29449,7 @@
           </a:bodyPr>
           <a:lstStyle/>
           <a:p>
-            <a:pPr algn="l"/>
+            <a:pPr algn="ctr"/>
             <a:r>
               <a:rPr sz="850" b="0" i="1">
                 <a:solidFill>
@@ -29606,7 +29484,7 @@
           </a:bodyPr>
           <a:lstStyle/>
           <a:p>
-            <a:pPr algn="l"/>
+            <a:pPr algn="ctr"/>
             <a:r>
               <a:rPr sz="900" b="0" i="0">
                 <a:solidFill>
@@ -29766,7 +29644,7 @@
           </a:bodyPr>
           <a:lstStyle/>
           <a:p>
-            <a:pPr algn="l"/>
+            <a:pPr algn="ctr"/>
             <a:r>
               <a:rPr sz="1300" b="1" i="0">
                 <a:solidFill>
@@ -29801,7 +29679,7 @@
           </a:bodyPr>
           <a:lstStyle/>
           <a:p>
-            <a:pPr algn="l"/>
+            <a:pPr algn="ctr"/>
             <a:r>
               <a:rPr sz="850" b="0" i="1">
                 <a:solidFill>
@@ -29836,7 +29714,7 @@
           </a:bodyPr>
           <a:lstStyle/>
           <a:p>
-            <a:pPr algn="l"/>
+            <a:pPr algn="ctr"/>
             <a:r>
               <a:rPr sz="900" b="0" i="0">
                 <a:solidFill>
@@ -29996,7 +29874,7 @@
           </a:bodyPr>
           <a:lstStyle/>
           <a:p>
-            <a:pPr algn="l"/>
+            <a:pPr algn="ctr"/>
             <a:r>
               <a:rPr sz="1300" b="1" i="0">
                 <a:solidFill>
@@ -30031,7 +29909,7 @@
           </a:bodyPr>
           <a:lstStyle/>
           <a:p>
-            <a:pPr algn="l"/>
+            <a:pPr algn="ctr"/>
             <a:r>
               <a:rPr sz="850" b="0" i="1">
                 <a:solidFill>
@@ -30066,7 +29944,7 @@
           </a:bodyPr>
           <a:lstStyle/>
           <a:p>
-            <a:pPr algn="l"/>
+            <a:pPr algn="ctr"/>
             <a:r>
               <a:rPr sz="900" b="0" i="0">
                 <a:solidFill>
@@ -30226,7 +30104,7 @@
           </a:bodyPr>
           <a:lstStyle/>
           <a:p>
-            <a:pPr algn="l"/>
+            <a:pPr algn="ctr"/>
             <a:r>
               <a:rPr sz="1300" b="1" i="0">
                 <a:solidFill>
@@ -30261,7 +30139,7 @@
           </a:bodyPr>
           <a:lstStyle/>
           <a:p>
-            <a:pPr algn="l"/>
+            <a:pPr algn="ctr"/>
             <a:r>
               <a:rPr sz="850" b="0" i="1">
                 <a:solidFill>
@@ -30296,7 +30174,7 @@
           </a:bodyPr>
           <a:lstStyle/>
           <a:p>
-            <a:pPr algn="l"/>
+            <a:pPr algn="ctr"/>
             <a:r>
               <a:rPr sz="900" b="0" i="0">
                 <a:solidFill>
@@ -30377,7 +30255,7 @@
           </a:bodyPr>
           <a:lstStyle/>
           <a:p>
-            <a:pPr algn="l"/>
+            <a:pPr algn="ctr"/>
             <a:r>
               <a:rPr sz="1050" b="0" i="0">
                 <a:solidFill>
@@ -30605,7 +30483,7 @@
           </a:bodyPr>
           <a:lstStyle/>
           <a:p>
-            <a:pPr algn="l"/>
+            <a:pPr algn="ctr"/>
             <a:r>
               <a:rPr sz="1000" b="1" i="0">
                 <a:solidFill>
@@ -30640,7 +30518,7 @@
           </a:bodyPr>
           <a:lstStyle/>
           <a:p>
-            <a:pPr algn="l"/>
+            <a:pPr algn="ctr"/>
             <a:r>
               <a:rPr sz="2400" b="1" i="0">
                 <a:solidFill>
@@ -30721,7 +30599,7 @@
           </a:bodyPr>
           <a:lstStyle/>
           <a:p>
-            <a:pPr algn="l"/>
+            <a:pPr algn="ctr"/>
             <a:r>
               <a:rPr sz="900" b="0" i="1">
                 <a:solidFill>
@@ -30884,7 +30762,7 @@
           </a:bodyPr>
           <a:lstStyle/>
           <a:p>
-            <a:pPr algn="l"/>
+            <a:pPr algn="ctr"/>
             <a:r>
               <a:rPr sz="850" b="1" i="0">
                 <a:solidFill>
@@ -30965,7 +30843,7 @@
           </a:bodyPr>
           <a:lstStyle/>
           <a:p>
-            <a:pPr algn="l"/>
+            <a:pPr algn="ctr"/>
             <a:r>
               <a:rPr sz="700" b="1" i="0">
                 <a:solidFill>
@@ -31090,7 +30968,7 @@
           </a:bodyPr>
           <a:lstStyle/>
           <a:p>
-            <a:pPr algn="l"/>
+            <a:pPr algn="ctr"/>
             <a:r>
               <a:rPr sz="800" b="1" i="0">
                 <a:solidFill>
@@ -31125,7 +31003,7 @@
           </a:bodyPr>
           <a:lstStyle/>
           <a:p>
-            <a:pPr algn="l"/>
+            <a:pPr algn="ctr"/>
             <a:r>
               <a:rPr sz="800" b="0" i="0">
                 <a:solidFill>
@@ -31251,7 +31129,7 @@
           </a:bodyPr>
           <a:lstStyle/>
           <a:p>
-            <a:pPr algn="l"/>
+            <a:pPr algn="ctr"/>
             <a:r>
               <a:rPr sz="800" b="1" i="0">
                 <a:solidFill>
@@ -31286,7 +31164,7 @@
           </a:bodyPr>
           <a:lstStyle/>
           <a:p>
-            <a:pPr algn="l"/>
+            <a:pPr algn="ctr"/>
             <a:r>
               <a:rPr sz="800" b="0" i="0">
                 <a:solidFill>
@@ -31412,7 +31290,7 @@
           </a:bodyPr>
           <a:lstStyle/>
           <a:p>
-            <a:pPr algn="l"/>
+            <a:pPr algn="ctr"/>
             <a:r>
               <a:rPr sz="800" b="1" i="0">
                 <a:solidFill>
@@ -31447,7 +31325,7 @@
           </a:bodyPr>
           <a:lstStyle/>
           <a:p>
-            <a:pPr algn="l"/>
+            <a:pPr algn="ctr"/>
             <a:r>
               <a:rPr sz="800" b="0" i="0">
                 <a:solidFill>
@@ -31529,7 +31407,7 @@
           </a:bodyPr>
           <a:lstStyle/>
           <a:p>
-            <a:pPr algn="l"/>
+            <a:pPr algn="ctr"/>
             <a:r>
               <a:rPr sz="850" b="1" i="0">
                 <a:solidFill>
@@ -31729,7 +31607,7 @@
           </a:bodyPr>
           <a:lstStyle/>
           <a:p>
-            <a:pPr algn="l"/>
+            <a:pPr algn="ctr"/>
             <a:r>
               <a:rPr sz="850" b="1" i="0">
                 <a:solidFill>
@@ -31810,7 +31688,7 @@
           </a:bodyPr>
           <a:lstStyle/>
           <a:p>
-            <a:pPr algn="l"/>
+            <a:pPr algn="ctr"/>
             <a:r>
               <a:rPr sz="700" b="1" i="0">
                 <a:solidFill>
@@ -31935,7 +31813,7 @@
           </a:bodyPr>
           <a:lstStyle/>
           <a:p>
-            <a:pPr algn="l"/>
+            <a:pPr algn="ctr"/>
             <a:r>
               <a:rPr sz="800" b="1" i="0">
                 <a:solidFill>
@@ -31970,7 +31848,7 @@
           </a:bodyPr>
           <a:lstStyle/>
           <a:p>
-            <a:pPr algn="l"/>
+            <a:pPr algn="ctr"/>
             <a:r>
               <a:rPr sz="800" b="0" i="0">
                 <a:solidFill>
@@ -32096,7 +31974,7 @@
           </a:bodyPr>
           <a:lstStyle/>
           <a:p>
-            <a:pPr algn="l"/>
+            <a:pPr algn="ctr"/>
             <a:r>
               <a:rPr sz="800" b="1" i="0">
                 <a:solidFill>
@@ -32131,7 +32009,7 @@
           </a:bodyPr>
           <a:lstStyle/>
           <a:p>
-            <a:pPr algn="l"/>
+            <a:pPr algn="ctr"/>
             <a:r>
               <a:rPr sz="800" b="0" i="0">
                 <a:solidFill>
@@ -32257,7 +32135,7 @@
           </a:bodyPr>
           <a:lstStyle/>
           <a:p>
-            <a:pPr algn="l"/>
+            <a:pPr algn="ctr"/>
             <a:r>
               <a:rPr sz="800" b="1" i="0">
                 <a:solidFill>
@@ -32292,7 +32170,7 @@
           </a:bodyPr>
           <a:lstStyle/>
           <a:p>
-            <a:pPr algn="l"/>
+            <a:pPr algn="ctr"/>
             <a:r>
               <a:rPr sz="800" b="0" i="0">
                 <a:solidFill>
@@ -32418,7 +32296,7 @@
           </a:bodyPr>
           <a:lstStyle/>
           <a:p>
-            <a:pPr algn="l"/>
+            <a:pPr algn="ctr"/>
             <a:r>
               <a:rPr sz="800" b="1" i="0">
                 <a:solidFill>
@@ -32453,7 +32331,7 @@
           </a:bodyPr>
           <a:lstStyle/>
           <a:p>
-            <a:pPr algn="l"/>
+            <a:pPr algn="ctr"/>
             <a:r>
               <a:rPr sz="800" b="0" i="0">
                 <a:solidFill>
@@ -32535,7 +32413,7 @@
           </a:bodyPr>
           <a:lstStyle/>
           <a:p>
-            <a:pPr algn="l"/>
+            <a:pPr algn="ctr"/>
             <a:r>
               <a:rPr sz="850" b="1" i="0">
                 <a:solidFill>
@@ -32736,7 +32614,7 @@
           </a:bodyPr>
           <a:lstStyle/>
           <a:p>
-            <a:pPr algn="l"/>
+            <a:pPr algn="ctr"/>
             <a:r>
               <a:rPr sz="850" b="1" i="0">
                 <a:solidFill>
@@ -32817,7 +32695,7 @@
           </a:bodyPr>
           <a:lstStyle/>
           <a:p>
-            <a:pPr algn="l"/>
+            <a:pPr algn="ctr"/>
             <a:r>
               <a:rPr sz="700" b="1" i="0">
                 <a:solidFill>
@@ -32942,7 +32820,7 @@
           </a:bodyPr>
           <a:lstStyle/>
           <a:p>
-            <a:pPr algn="l"/>
+            <a:pPr algn="ctr"/>
             <a:r>
               <a:rPr sz="800" b="1" i="0">
                 <a:solidFill>
@@ -32978,7 +32856,7 @@
           </a:bodyPr>
           <a:lstStyle/>
           <a:p>
-            <a:pPr algn="l"/>
+            <a:pPr algn="ctr"/>
             <a:r>
               <a:rPr sz="800" b="0" i="0">
                 <a:solidFill>
@@ -33105,7 +32983,7 @@
           </a:bodyPr>
           <a:lstStyle/>
           <a:p>
-            <a:pPr algn="l"/>
+            <a:pPr algn="ctr"/>
             <a:r>
               <a:rPr sz="800" b="1" i="0">
                 <a:solidFill>
@@ -33141,7 +33019,7 @@
           </a:bodyPr>
           <a:lstStyle/>
           <a:p>
-            <a:pPr algn="l"/>
+            <a:pPr algn="ctr"/>
             <a:r>
               <a:rPr sz="800" b="0" i="0">
                 <a:solidFill>
@@ -33267,7 +33145,7 @@
           </a:bodyPr>
           <a:lstStyle/>
           <a:p>
-            <a:pPr algn="l"/>
+            <a:pPr algn="ctr"/>
             <a:r>
               <a:rPr sz="800" b="1" i="0">
                 <a:solidFill>
@@ -33303,7 +33181,7 @@
           </a:bodyPr>
           <a:lstStyle/>
           <a:p>
-            <a:pPr algn="l"/>
+            <a:pPr algn="ctr"/>
             <a:r>
               <a:rPr sz="800" b="0" i="0">
                 <a:solidFill>
@@ -33385,7 +33263,7 @@
           </a:bodyPr>
           <a:lstStyle/>
           <a:p>
-            <a:pPr algn="l"/>
+            <a:pPr algn="ctr"/>
             <a:r>
               <a:rPr sz="850" b="1" i="0">
                 <a:solidFill>
@@ -33586,7 +33464,7 @@
           </a:bodyPr>
           <a:lstStyle/>
           <a:p>
-            <a:pPr algn="l"/>
+            <a:pPr algn="ctr"/>
             <a:r>
               <a:rPr sz="850" b="1" i="0">
                 <a:solidFill>
@@ -33667,7 +33545,7 @@
           </a:bodyPr>
           <a:lstStyle/>
           <a:p>
-            <a:pPr algn="l"/>
+            <a:pPr algn="ctr"/>
             <a:r>
               <a:rPr sz="700" b="1" i="0">
                 <a:solidFill>
@@ -33792,7 +33670,7 @@
           </a:bodyPr>
           <a:lstStyle/>
           <a:p>
-            <a:pPr algn="l"/>
+            <a:pPr algn="ctr"/>
             <a:r>
               <a:rPr sz="800" b="1" i="0">
                 <a:solidFill>
@@ -33827,7 +33705,7 @@
           </a:bodyPr>
           <a:lstStyle/>
           <a:p>
-            <a:pPr algn="l"/>
+            <a:pPr algn="ctr"/>
             <a:r>
               <a:rPr sz="800" b="0" i="0">
                 <a:solidFill>
@@ -33911,7 +33789,7 @@
           </a:bodyPr>
           <a:lstStyle/>
           <a:p>
-            <a:pPr algn="l"/>
+            <a:pPr algn="ctr"/>
             <a:r>
               <a:rPr sz="850" b="1" i="0">
                 <a:solidFill>
@@ -33992,7 +33870,7 @@
           </a:bodyPr>
           <a:lstStyle/>
           <a:p>
-            <a:pPr algn="l"/>
+            <a:pPr algn="ctr"/>
             <a:r>
               <a:rPr sz="1800" b="1" i="0">
                 <a:solidFill>
@@ -34027,7 +33905,7 @@
           </a:bodyPr>
           <a:lstStyle/>
           <a:p>
-            <a:pPr algn="l"/>
+            <a:pPr algn="ctr"/>
             <a:r>
               <a:rPr sz="750" b="0" i="0">
                 <a:solidFill>
@@ -34062,7 +33940,7 @@
           </a:bodyPr>
           <a:lstStyle/>
           <a:p>
-            <a:pPr algn="l"/>
+            <a:pPr algn="ctr"/>
             <a:r>
               <a:rPr sz="1800" b="1" i="0">
                 <a:solidFill>
@@ -34097,7 +33975,7 @@
           </a:bodyPr>
           <a:lstStyle/>
           <a:p>
-            <a:pPr algn="l"/>
+            <a:pPr algn="ctr"/>
             <a:r>
               <a:rPr sz="750" b="0" i="0">
                 <a:solidFill>
@@ -34132,7 +34010,7 @@
           </a:bodyPr>
           <a:lstStyle/>
           <a:p>
-            <a:pPr algn="l"/>
+            <a:pPr algn="ctr"/>
             <a:r>
               <a:rPr sz="1800" b="1" i="0">
                 <a:solidFill>
@@ -34167,7 +34045,7 @@
           </a:bodyPr>
           <a:lstStyle/>
           <a:p>
-            <a:pPr algn="l"/>
+            <a:pPr algn="ctr"/>
             <a:r>
               <a:rPr sz="750" b="0" i="0">
                 <a:solidFill>
@@ -34202,7 +34080,7 @@
           </a:bodyPr>
           <a:lstStyle/>
           <a:p>
-            <a:pPr algn="l"/>
+            <a:pPr algn="ctr"/>
             <a:r>
               <a:rPr sz="1800" b="1" i="0">
                 <a:solidFill>
@@ -34237,7 +34115,7 @@
           </a:bodyPr>
           <a:lstStyle/>
           <a:p>
-            <a:pPr algn="l"/>
+            <a:pPr algn="ctr"/>
             <a:r>
               <a:rPr sz="750" b="0" i="0">
                 <a:solidFill>
@@ -34272,7 +34150,7 @@
           </a:bodyPr>
           <a:lstStyle/>
           <a:p>
-            <a:pPr algn="l"/>
+            <a:pPr algn="ctr"/>
             <a:r>
               <a:rPr sz="1800" b="1" i="0">
                 <a:solidFill>
@@ -34307,7 +34185,7 @@
           </a:bodyPr>
           <a:lstStyle/>
           <a:p>
-            <a:pPr algn="l"/>
+            <a:pPr algn="ctr"/>
             <a:r>
               <a:rPr sz="750" b="0" i="0">
                 <a:solidFill>
@@ -34342,7 +34220,7 @@
           </a:bodyPr>
           <a:lstStyle/>
           <a:p>
-            <a:pPr algn="l"/>
+            <a:pPr algn="ctr"/>
             <a:r>
               <a:rPr sz="1800" b="1" i="0">
                 <a:solidFill>
@@ -34377,7 +34255,7 @@
           </a:bodyPr>
           <a:lstStyle/>
           <a:p>
-            <a:pPr algn="l"/>
+            <a:pPr algn="ctr"/>
             <a:r>
               <a:rPr sz="750" b="0" i="0">
                 <a:solidFill>
@@ -34412,7 +34290,7 @@
           </a:bodyPr>
           <a:lstStyle/>
           <a:p>
-            <a:pPr algn="l"/>
+            <a:pPr algn="ctr"/>
             <a:r>
               <a:rPr sz="1800" b="1" i="0">
                 <a:solidFill>
@@ -34447,7 +34325,7 @@
           </a:bodyPr>
           <a:lstStyle/>
           <a:p>
-            <a:pPr algn="l"/>
+            <a:pPr algn="ctr"/>
             <a:r>
               <a:rPr sz="750" b="0" i="0">
                 <a:solidFill>

</xml_diff>